<commit_message>
docs: añadir vídeo demo y corregir la presentación
- doc/demo-todo-serverless.gif: demo grabada de la app en producción
  (crear, completar, editar y borrar tareas contra la API real).
- doc/presentacion.pptx: corregido un error de generación.

Co-Authored-By: Claude Sonnet 5 <noreply@anthropic.com>
</commit_message>
<xml_diff>
--- a/doc/presentacion.pptx
+++ b/doc/presentacion.pptx
@@ -4,6 +4,9 @@
   <p:sldMasterIdLst>
     <p:sldMasterId id="2147483648" r:id="rId1"/>
   </p:sldMasterIdLst>
+  <p:notesMasterIdLst>
+    <p:notesMasterId r:id="rId12"/>
+  </p:notesMasterIdLst>
   <p:sldIdLst>
     <p:sldId id="256" r:id="rId2"/>
     <p:sldId id="257" r:id="rId3"/>
@@ -16,9 +19,6 @@
     <p:sldId id="264" r:id="rId10"/>
     <p:sldId id="265" r:id="rId11"/>
   </p:sldIdLst>
-  <p:notesMasterIdLst>
-    <p:notesMasterId r:id="rId12"/>
-  </p:notesMasterIdLst>
   <p:sldSz cx="12192000" cy="6858000"/>
   <p:notesSz cx="6858000" cy="12192000"/>
   <p:defaultTextStyle>
@@ -113,6 +113,11 @@
       </a:defRPr>
     </a:lvl9pPr>
   </p:defaultTextStyle>
+  <p:extLst>
+    <p:ext uri="{EFAFB233-063F-42B5-8137-9DF3F51BA10A}">
+      <p15:sldGuideLst xmlns:p15="http://schemas.microsoft.com/office/powerpoint/2012/main"/>
+    </p:ext>
+  </p:extLst>
 </p:presentation>
 </file>
 
@@ -138,234 +143,10 @@
           <a:chExt cx="0" cy="0"/>
         </a:xfrm>
       </p:grpSpPr>
-      <p:sp>
-        <p:nvSpPr>
-          <p:cNvPr id="2" name="Header Placeholder 1"/>
-          <p:cNvSpPr>
-            <a:spLocks noGrp="1"/>
-          </p:cNvSpPr>
-          <p:nvPr>
-            <p:ph type="hdr" sz="quarter"/>
-          </p:nvPr>
-        </p:nvSpPr>
-        <p:spPr>
-          <a:xfrm>
-            <a:off x="0" y="0"/>
-            <a:ext cx="2971800" cy="458788"/>
-          </a:xfrm>
-          <a:prstGeom prst="rect">
-            <a:avLst/>
-          </a:prstGeom>
-        </p:spPr>
-        <p:txBody>
-          <a:bodyPr vert="horz" lIns="91440" tIns="45720" rIns="91440" bIns="45720" rtlCol="0"/>
-          <a:lstStyle>
-            <a:lvl1pPr algn="l">
-              <a:defRPr sz="1200"/>
-            </a:lvl1pPr>
-          </a:lstStyle>
-          <a:p>
-            <a:endParaRPr lang="en-US"/>
-          </a:p>
-        </p:txBody>
-      </p:sp>
-      <p:sp>
-        <p:nvSpPr>
-          <p:cNvPr id="3" name="Date Placeholder 2"/>
-          <p:cNvSpPr>
-            <a:spLocks noGrp="1"/>
-          </p:cNvSpPr>
-          <p:nvPr>
-            <p:ph type="dt" idx="1"/>
-          </p:nvPr>
-        </p:nvSpPr>
-        <p:spPr>
-          <a:xfrm>
-            <a:off x="3884613" y="0"/>
-            <a:ext cx="2971800" cy="458788"/>
-          </a:xfrm>
-          <a:prstGeom prst="rect">
-            <a:avLst/>
-          </a:prstGeom>
-        </p:spPr>
-        <p:txBody>
-          <a:bodyPr vert="horz" lIns="91440" tIns="45720" rIns="91440" bIns="45720" rtlCol="0"/>
-          <a:lstStyle>
-            <a:lvl1pPr algn="r">
-              <a:defRPr sz="1200"/>
-            </a:lvl1pPr>
-          </a:lstStyle>
-          <a:p>
-            <a:fld id="{5282F153-3F37-0F45-9E97-73ACFA13230C}" type="datetimeFigureOut">
-              <a:rPr lang="en-US"/>
-              <a:t>7/23/19</a:t>
-            </a:fld>
-            <a:endParaRPr lang="en-US"/>
-          </a:p>
-        </p:txBody>
-      </p:sp>
-      <p:sp>
-        <p:nvSpPr>
-          <p:cNvPr id="4" name="Slide Image Placeholder 3"/>
-          <p:cNvSpPr>
-            <a:spLocks noGrp="1" noRot="1" noChangeAspect="1"/>
-          </p:cNvSpPr>
-          <p:nvPr>
-            <p:ph type="sldImg" idx="2"/>
-          </p:nvPr>
-        </p:nvSpPr>
-        <p:spPr>
-          <a:xfrm>
-            <a:off x="685800" y="1143000"/>
-            <a:ext cx="5486400" cy="3086100"/>
-          </a:xfrm>
-          <a:prstGeom prst="rect">
-            <a:avLst/>
-          </a:prstGeom>
-          <a:noFill/>
-          <a:ln w="12700">
-            <a:solidFill>
-              <a:prstClr val="black"/>
-            </a:solidFill>
-          </a:ln>
-        </p:spPr>
-        <p:txBody>
-          <a:bodyPr vert="horz" lIns="91440" tIns="45720" rIns="91440" bIns="45720" rtlCol="0" anchor="ctr"/>
-          <a:lstStyle/>
-          <a:p>
-            <a:endParaRPr lang="en-US"/>
-          </a:p>
-        </p:txBody>
-      </p:sp>
-      <p:sp>
-        <p:nvSpPr>
-          <p:cNvPr id="5" name="Notes Placeholder 4"/>
-          <p:cNvSpPr>
-            <a:spLocks noGrp="1"/>
-          </p:cNvSpPr>
-          <p:nvPr>
-            <p:ph type="body" sz="quarter" idx="3"/>
-          </p:nvPr>
-        </p:nvSpPr>
-        <p:spPr>
-          <a:xfrm>
-            <a:off x="685800" y="4400550"/>
-            <a:ext cx="5486400" cy="3600450"/>
-          </a:xfrm>
-          <a:prstGeom prst="rect">
-            <a:avLst/>
-          </a:prstGeom>
-        </p:spPr>
-        <p:txBody>
-          <a:bodyPr vert="horz" lIns="91440" tIns="45720" rIns="91440" bIns="45720" rtlCol="0"/>
-          <a:lstStyle/>
-          <a:p>
-            <a:pPr lvl="0"/>
-            <a:r>
-              <a:rPr lang="en-US"/>
-              <a:t>Click to edit Master text styles</a:t>
-            </a:r>
-          </a:p>
-          <a:p>
-            <a:pPr lvl="1"/>
-            <a:r>
-              <a:rPr lang="en-US"/>
-              <a:t>Second level</a:t>
-            </a:r>
-          </a:p>
-          <a:p>
-            <a:pPr lvl="2"/>
-            <a:r>
-              <a:rPr lang="en-US"/>
-              <a:t>Third level</a:t>
-            </a:r>
-          </a:p>
-          <a:p>
-            <a:pPr lvl="3"/>
-            <a:r>
-              <a:rPr lang="en-US"/>
-              <a:t>Fourth level</a:t>
-            </a:r>
-          </a:p>
-          <a:p>
-            <a:pPr lvl="4"/>
-            <a:r>
-              <a:rPr lang="en-US"/>
-              <a:t>Fifth level</a:t>
-            </a:r>
-          </a:p>
-        </p:txBody>
-      </p:sp>
-      <p:sp>
-        <p:nvSpPr>
-          <p:cNvPr id="6" name="Footer Placeholder 5"/>
-          <p:cNvSpPr>
-            <a:spLocks noGrp="1"/>
-          </p:cNvSpPr>
-          <p:nvPr>
-            <p:ph type="ftr" sz="quarter" idx="4"/>
-          </p:nvPr>
-        </p:nvSpPr>
-        <p:spPr>
-          <a:xfrm>
-            <a:off x="0" y="8685213"/>
-            <a:ext cx="2971800" cy="458787"/>
-          </a:xfrm>
-          <a:prstGeom prst="rect">
-            <a:avLst/>
-          </a:prstGeom>
-        </p:spPr>
-        <p:txBody>
-          <a:bodyPr vert="horz" lIns="91440" tIns="45720" rIns="91440" bIns="45720" rtlCol="0" anchor="b"/>
-          <a:lstStyle>
-            <a:lvl1pPr algn="l">
-              <a:defRPr sz="1200"/>
-            </a:lvl1pPr>
-          </a:lstStyle>
-          <a:p>
-            <a:endParaRPr lang="en-US"/>
-          </a:p>
-        </p:txBody>
-      </p:sp>
-      <p:sp>
-        <p:nvSpPr>
-          <p:cNvPr id="7" name="Slide Number Placeholder 6"/>
-          <p:cNvSpPr>
-            <a:spLocks noGrp="1"/>
-          </p:cNvSpPr>
-          <p:nvPr>
-            <p:ph type="sldNum" sz="quarter" idx="5"/>
-          </p:nvPr>
-        </p:nvSpPr>
-        <p:spPr>
-          <a:xfrm>
-            <a:off x="3884613" y="8685213"/>
-            <a:ext cx="2971800" cy="458787"/>
-          </a:xfrm>
-          <a:prstGeom prst="rect">
-            <a:avLst/>
-          </a:prstGeom>
-        </p:spPr>
-        <p:txBody>
-          <a:bodyPr vert="horz" lIns="91440" tIns="45720" rIns="91440" bIns="45720" rtlCol="0" anchor="b"/>
-          <a:lstStyle>
-            <a:lvl1pPr algn="r">
-              <a:defRPr sz="1200"/>
-            </a:lvl1pPr>
-          </a:lstStyle>
-          <a:p>
-            <a:fld id="{CE5E9CC1-C706-0F49-92D6-E571CC5EEA8F}" type="slidenum">
-              <a:rPr lang="en-US"/>
-              <a:t>‹#›</a:t>
-            </a:fld>
-            <a:endParaRPr lang="en-US"/>
-          </a:p>
-        </p:txBody>
-      </p:sp>
     </p:spTree>
     <p:extLst>
       <p:ext uri="{BB962C8B-B14F-4D97-AF65-F5344CB8AC3E}">
-        <p14:creationId xmlns:p14="http://schemas.microsoft.com/office/powerpoint/2010/main" val="1024086991"/>
+        <p14:creationId xmlns:p14="http://schemas.microsoft.com/office/powerpoint/2010/main" val="598242573"/>
       </p:ext>
     </p:extLst>
   </p:cSld>
@@ -509,10 +290,6 @@
           <a:bodyPr/>
           <a:lstStyle/>
           <a:p>
-            <a:r>
-              <a:rPr lang="en-US" dirty="0"/>
-              <a:t/>
-            </a:r>
             <a:endParaRPr lang="en-US" dirty="0"/>
           </a:p>
         </p:txBody>
@@ -597,10 +374,6 @@
           <a:bodyPr/>
           <a:lstStyle/>
           <a:p>
-            <a:r>
-              <a:rPr lang="en-US" dirty="0"/>
-              <a:t/>
-            </a:r>
             <a:endParaRPr lang="en-US" dirty="0"/>
           </a:p>
         </p:txBody>
@@ -685,10 +458,6 @@
           <a:bodyPr/>
           <a:lstStyle/>
           <a:p>
-            <a:r>
-              <a:rPr lang="en-US" dirty="0"/>
-              <a:t/>
-            </a:r>
             <a:endParaRPr lang="en-US" dirty="0"/>
           </a:p>
         </p:txBody>
@@ -773,10 +542,6 @@
           <a:bodyPr/>
           <a:lstStyle/>
           <a:p>
-            <a:r>
-              <a:rPr lang="en-US" dirty="0"/>
-              <a:t/>
-            </a:r>
             <a:endParaRPr lang="en-US" dirty="0"/>
           </a:p>
         </p:txBody>
@@ -861,10 +626,6 @@
           <a:bodyPr/>
           <a:lstStyle/>
           <a:p>
-            <a:r>
-              <a:rPr lang="en-US" dirty="0"/>
-              <a:t/>
-            </a:r>
             <a:endParaRPr lang="en-US" dirty="0"/>
           </a:p>
         </p:txBody>
@@ -949,10 +710,6 @@
           <a:bodyPr/>
           <a:lstStyle/>
           <a:p>
-            <a:r>
-              <a:rPr lang="en-US" dirty="0"/>
-              <a:t/>
-            </a:r>
             <a:endParaRPr lang="en-US" dirty="0"/>
           </a:p>
         </p:txBody>
@@ -1037,10 +794,6 @@
           <a:bodyPr/>
           <a:lstStyle/>
           <a:p>
-            <a:r>
-              <a:rPr lang="en-US" dirty="0"/>
-              <a:t/>
-            </a:r>
             <a:endParaRPr lang="en-US" dirty="0"/>
           </a:p>
         </p:txBody>
@@ -1125,10 +878,6 @@
           <a:bodyPr/>
           <a:lstStyle/>
           <a:p>
-            <a:r>
-              <a:rPr lang="en-US" dirty="0"/>
-              <a:t/>
-            </a:r>
             <a:endParaRPr lang="en-US" dirty="0"/>
           </a:p>
         </p:txBody>
@@ -1213,10 +962,6 @@
           <a:bodyPr/>
           <a:lstStyle/>
           <a:p>
-            <a:r>
-              <a:rPr lang="en-US" dirty="0"/>
-              <a:t/>
-            </a:r>
             <a:endParaRPr lang="en-US" dirty="0"/>
           </a:p>
         </p:txBody>
@@ -1301,10 +1046,6 @@
           <a:bodyPr/>
           <a:lstStyle/>
           <a:p>
-            <a:r>
-              <a:rPr lang="en-US" dirty="0"/>
-              <a:t/>
-            </a:r>
             <a:endParaRPr lang="en-US" dirty="0"/>
           </a:p>
         </p:txBody>
@@ -1378,6 +1119,11 @@
 <file path=ppt/slideMasters/slideMaster1.xml><?xml version="1.0" encoding="utf-8"?>
 <p:sldMaster xmlns:a="http://schemas.openxmlformats.org/drawingml/2006/main" xmlns:r="http://schemas.openxmlformats.org/officeDocument/2006/relationships" xmlns:p="http://schemas.openxmlformats.org/presentationml/2006/main">
   <p:cSld>
+    <p:bg>
+      <p:bgRef idx="1001">
+        <a:schemeClr val="bg1"/>
+      </p:bgRef>
+    </p:bg>
     <p:spTree>
       <p:nvGrpSpPr>
         <p:cNvPr id="1" name=""/>
@@ -1660,6 +1406,7 @@
         <a:solidFill>
           <a:srgbClr val="151A2B"/>
         </a:solidFill>
+        <a:effectLst/>
       </p:bgPr>
     </p:bg>
     <p:spTree>
@@ -1695,6 +1442,13 @@
           </a:solidFill>
           <a:ln/>
         </p:spPr>
+        <p:txBody>
+          <a:bodyPr/>
+          <a:lstStyle/>
+          <a:p>
+            <a:endParaRPr lang="en-US"/>
+          </a:p>
+        </p:txBody>
       </p:sp>
       <p:sp>
         <p:nvSpPr>
@@ -1718,6 +1472,13 @@
             <a:prstDash val="solid"/>
           </a:ln>
         </p:spPr>
+        <p:txBody>
+          <a:bodyPr/>
+          <a:lstStyle/>
+          <a:p>
+            <a:endParaRPr lang="en-US"/>
+          </a:p>
+        </p:txBody>
       </p:sp>
       <p:sp>
         <p:nvSpPr>
@@ -1728,7 +1489,7 @@
         <p:spPr>
           <a:xfrm>
             <a:off x="10607040" y="5760720"/>
-            <a:ext cx="640080" cy="-914400"/>
+            <a:ext cx="640080" cy="0"/>
           </a:xfrm>
           <a:prstGeom prst="line">
             <a:avLst/>
@@ -1741,6 +1502,13 @@
             <a:prstDash val="solid"/>
           </a:ln>
         </p:spPr>
+        <p:txBody>
+          <a:bodyPr/>
+          <a:lstStyle/>
+          <a:p>
+            <a:endParaRPr lang="en-US"/>
+          </a:p>
+        </p:txBody>
       </p:sp>
       <p:sp>
         <p:nvSpPr>
@@ -1751,7 +1519,7 @@
         <p:spPr>
           <a:xfrm>
             <a:off x="11247120" y="4846320"/>
-            <a:ext cx="-2194560" cy="1188720"/>
+            <a:ext cx="0" cy="1188720"/>
           </a:xfrm>
           <a:prstGeom prst="line">
             <a:avLst/>
@@ -1764,6 +1532,13 @@
             <a:prstDash val="solid"/>
           </a:ln>
         </p:spPr>
+        <p:txBody>
+          <a:bodyPr/>
+          <a:lstStyle/>
+          <a:p>
+            <a:endParaRPr lang="en-US"/>
+          </a:p>
+        </p:txBody>
       </p:sp>
       <p:sp>
         <p:nvSpPr>
@@ -1787,6 +1562,13 @@
             <a:prstDash val="solid"/>
           </a:ln>
         </p:spPr>
+        <p:txBody>
+          <a:bodyPr/>
+          <a:lstStyle/>
+          <a:p>
+            <a:endParaRPr lang="en-US"/>
+          </a:p>
+        </p:txBody>
       </p:sp>
       <p:sp>
         <p:nvSpPr>
@@ -1807,6 +1589,13 @@
           </a:solidFill>
           <a:ln/>
         </p:spPr>
+        <p:txBody>
+          <a:bodyPr/>
+          <a:lstStyle/>
+          <a:p>
+            <a:endParaRPr lang="en-US"/>
+          </a:p>
+        </p:txBody>
       </p:sp>
       <p:sp>
         <p:nvSpPr>
@@ -1827,6 +1616,13 @@
           </a:solidFill>
           <a:ln/>
         </p:spPr>
+        <p:txBody>
+          <a:bodyPr/>
+          <a:lstStyle/>
+          <a:p>
+            <a:endParaRPr lang="en-US"/>
+          </a:p>
+        </p:txBody>
       </p:sp>
       <p:sp>
         <p:nvSpPr>
@@ -1847,6 +1643,13 @@
           </a:solidFill>
           <a:ln/>
         </p:spPr>
+        <p:txBody>
+          <a:bodyPr/>
+          <a:lstStyle/>
+          <a:p>
+            <a:endParaRPr lang="en-US"/>
+          </a:p>
+        </p:txBody>
       </p:sp>
       <p:sp>
         <p:nvSpPr>
@@ -1867,6 +1670,13 @@
           </a:solidFill>
           <a:ln/>
         </p:spPr>
+        <p:txBody>
+          <a:bodyPr/>
+          <a:lstStyle/>
+          <a:p>
+            <a:endParaRPr lang="en-US"/>
+          </a:p>
+        </p:txBody>
       </p:sp>
       <p:sp>
         <p:nvSpPr>
@@ -1887,6 +1697,13 @@
           </a:solidFill>
           <a:ln/>
         </p:spPr>
+        <p:txBody>
+          <a:bodyPr/>
+          <a:lstStyle/>
+          <a:p>
+            <a:endParaRPr lang="en-US"/>
+          </a:p>
+        </p:txBody>
       </p:sp>
       <p:sp>
         <p:nvSpPr>
@@ -1909,11 +1726,11 @@
           <a:bodyPr wrap="square" lIns="0" tIns="0" rIns="0" bIns="0" rtlCol="0" anchor="ctr"/>
           <a:lstStyle/>
           <a:p>
-            <a:pPr indent="0" marL="0">
-              <a:buNone/>
-            </a:pPr>
-            <a:r>
-              <a:rPr lang="en-US" sz="1400" b="1" spc="300" kern="0" dirty="0">
+            <a:pPr marL="0" indent="0">
+              <a:buNone/>
+            </a:pPr>
+            <a:r>
+              <a:rPr lang="en-US" sz="1400" b="1" kern="0" spc="300" dirty="0">
                 <a:solidFill>
                   <a:srgbClr val="FF9900"/>
                 </a:solidFill>
@@ -1948,7 +1765,7 @@
           <a:bodyPr wrap="square" lIns="0" tIns="0" rIns="0" bIns="0" rtlCol="0" anchor="ctr"/>
           <a:lstStyle/>
           <a:p>
-            <a:pPr indent="0" marL="0">
+            <a:pPr marL="0" indent="0">
               <a:buNone/>
             </a:pPr>
             <a:r>
@@ -1987,7 +1804,7 @@
           <a:bodyPr wrap="square" lIns="0" tIns="0" rIns="0" bIns="0" rtlCol="0" anchor="ctr"/>
           <a:lstStyle/>
           <a:p>
-            <a:pPr indent="0" marL="0">
+            <a:pPr marL="0" indent="0">
               <a:buNone/>
             </a:pPr>
             <a:r>
@@ -2026,7 +1843,7 @@
           <a:bodyPr wrap="square" lIns="0" tIns="0" rIns="0" bIns="0" rtlCol="0" anchor="ctr"/>
           <a:lstStyle/>
           <a:p>
-            <a:pPr indent="0" marL="0">
+            <a:pPr marL="0" indent="0">
               <a:buNone/>
             </a:pPr>
             <a:r>
@@ -2060,6 +1877,7 @@
         <a:solidFill>
           <a:srgbClr val="151A2B"/>
         </a:solidFill>
+        <a:effectLst/>
       </p:bgPr>
     </p:bg>
     <p:spTree>
@@ -2097,11 +1915,11 @@
           <a:bodyPr wrap="square" lIns="0" tIns="0" rIns="0" bIns="0" rtlCol="0" anchor="ctr"/>
           <a:lstStyle/>
           <a:p>
-            <a:pPr indent="0" marL="0">
-              <a:buNone/>
-            </a:pPr>
-            <a:r>
-              <a:rPr lang="en-US" sz="1400" b="1" spc="300" kern="0" dirty="0">
+            <a:pPr marL="0" indent="0">
+              <a:buNone/>
+            </a:pPr>
+            <a:r>
+              <a:rPr lang="en-US" sz="1400" b="1" kern="0" spc="300" dirty="0">
                 <a:solidFill>
                   <a:srgbClr val="FF9900"/>
                 </a:solidFill>
@@ -2136,7 +1954,7 @@
           <a:bodyPr wrap="square" lIns="0" tIns="0" rIns="0" bIns="0" rtlCol="0" anchor="ctr"/>
           <a:lstStyle/>
           <a:p>
-            <a:pPr indent="0" marL="0">
+            <a:pPr marL="0" indent="0">
               <a:buNone/>
             </a:pPr>
             <a:r>
@@ -2173,6 +1991,13 @@
           </a:solidFill>
           <a:ln/>
         </p:spPr>
+        <p:txBody>
+          <a:bodyPr/>
+          <a:lstStyle/>
+          <a:p>
+            <a:endParaRPr lang="en-US"/>
+          </a:p>
+        </p:txBody>
       </p:sp>
       <p:sp>
         <p:nvSpPr>
@@ -2195,7 +2020,7 @@
           <a:bodyPr wrap="square" lIns="0" tIns="0" rIns="0" bIns="0" rtlCol="0" anchor="ctr"/>
           <a:lstStyle/>
           <a:p>
-            <a:pPr indent="0" marL="0">
+            <a:pPr marL="0" indent="0">
               <a:buNone/>
             </a:pPr>
             <a:r>
@@ -2234,7 +2059,7 @@
           <a:bodyPr wrap="square" lIns="0" tIns="0" rIns="0" bIns="0" rtlCol="0" anchor="ctr"/>
           <a:lstStyle/>
           <a:p>
-            <a:pPr indent="0" marL="0">
+            <a:pPr marL="0" indent="0">
               <a:buNone/>
             </a:pPr>
             <a:r>
@@ -2271,6 +2096,13 @@
           </a:solidFill>
           <a:ln/>
         </p:spPr>
+        <p:txBody>
+          <a:bodyPr/>
+          <a:lstStyle/>
+          <a:p>
+            <a:endParaRPr lang="en-US"/>
+          </a:p>
+        </p:txBody>
       </p:sp>
       <p:sp>
         <p:nvSpPr>
@@ -2293,7 +2125,7 @@
           <a:bodyPr wrap="square" lIns="0" tIns="0" rIns="0" bIns="0" rtlCol="0" anchor="ctr"/>
           <a:lstStyle/>
           <a:p>
-            <a:pPr indent="0" marL="0">
+            <a:pPr marL="0" indent="0">
               <a:buNone/>
             </a:pPr>
             <a:r>
@@ -2332,7 +2164,7 @@
           <a:bodyPr wrap="square" lIns="0" tIns="0" rIns="0" bIns="0" rtlCol="0" anchor="ctr"/>
           <a:lstStyle/>
           <a:p>
-            <a:pPr indent="0" marL="0">
+            <a:pPr marL="0" indent="0">
               <a:buNone/>
             </a:pPr>
             <a:r>
@@ -2369,6 +2201,13 @@
           </a:solidFill>
           <a:ln/>
         </p:spPr>
+        <p:txBody>
+          <a:bodyPr/>
+          <a:lstStyle/>
+          <a:p>
+            <a:endParaRPr lang="en-US"/>
+          </a:p>
+        </p:txBody>
       </p:sp>
       <p:sp>
         <p:nvSpPr>
@@ -2391,7 +2230,7 @@
           <a:bodyPr wrap="square" lIns="0" tIns="0" rIns="0" bIns="0" rtlCol="0" anchor="ctr"/>
           <a:lstStyle/>
           <a:p>
-            <a:pPr indent="0" marL="0">
+            <a:pPr marL="0" indent="0">
               <a:buNone/>
             </a:pPr>
             <a:r>
@@ -2430,7 +2269,7 @@
           <a:bodyPr wrap="square" lIns="0" tIns="0" rIns="0" bIns="0" rtlCol="0" anchor="ctr"/>
           <a:lstStyle/>
           <a:p>
-            <a:pPr indent="0" marL="0">
+            <a:pPr marL="0" indent="0">
               <a:buNone/>
             </a:pPr>
             <a:r>
@@ -2464,6 +2303,7 @@
         <a:solidFill>
           <a:srgbClr val="F7F8FB"/>
         </a:solidFill>
+        <a:effectLst/>
       </p:bgPr>
     </p:bg>
     <p:spTree>
@@ -2501,11 +2341,11 @@
           <a:bodyPr wrap="square" lIns="0" tIns="0" rIns="0" bIns="0" rtlCol="0" anchor="ctr"/>
           <a:lstStyle/>
           <a:p>
-            <a:pPr indent="0" marL="0">
-              <a:buNone/>
-            </a:pPr>
-            <a:r>
-              <a:rPr lang="en-US" sz="1200" b="1" spc="200" kern="0" dirty="0">
+            <a:pPr marL="0" indent="0">
+              <a:buNone/>
+            </a:pPr>
+            <a:r>
+              <a:rPr lang="en-US" sz="1200" b="1" kern="0" spc="200" dirty="0">
                 <a:solidFill>
                   <a:srgbClr val="FF9900"/>
                 </a:solidFill>
@@ -2540,7 +2380,7 @@
           <a:bodyPr wrap="square" lIns="0" tIns="0" rIns="0" bIns="0" rtlCol="0" anchor="ctr"/>
           <a:lstStyle/>
           <a:p>
-            <a:pPr indent="0" marL="0">
+            <a:pPr marL="0" indent="0">
               <a:buNone/>
             </a:pPr>
             <a:r>
@@ -2579,6 +2419,13 @@
           </a:solidFill>
           <a:ln/>
         </p:spPr>
+        <p:txBody>
+          <a:bodyPr/>
+          <a:lstStyle/>
+          <a:p>
+            <a:endParaRPr lang="en-US"/>
+          </a:p>
+        </p:txBody>
       </p:sp>
       <p:sp>
         <p:nvSpPr>
@@ -2601,7 +2448,7 @@
           <a:bodyPr wrap="square" lIns="0" tIns="0" rIns="0" bIns="0" rtlCol="0" anchor="ctr"/>
           <a:lstStyle/>
           <a:p>
-            <a:pPr algn="ctr" indent="0" marL="0">
+            <a:pPr marL="0" indent="0" algn="ctr">
               <a:buNone/>
             </a:pPr>
             <a:r>
@@ -2640,7 +2487,7 @@
           <a:bodyPr wrap="square" lIns="0" tIns="0" rIns="0" bIns="0" rtlCol="0" anchor="ctr"/>
           <a:lstStyle/>
           <a:p>
-            <a:pPr indent="0" marL="0">
+            <a:pPr marL="0" indent="0">
               <a:buNone/>
             </a:pPr>
             <a:r>
@@ -2679,7 +2526,7 @@
           <a:bodyPr wrap="square" lIns="0" tIns="0" rIns="0" bIns="0" rtlCol="0" anchor="ctr"/>
           <a:lstStyle/>
           <a:p>
-            <a:pPr indent="0" marL="0">
+            <a:pPr marL="0" indent="0">
               <a:buNone/>
             </a:pPr>
             <a:r>
@@ -2718,6 +2565,13 @@
           </a:solidFill>
           <a:ln/>
         </p:spPr>
+        <p:txBody>
+          <a:bodyPr/>
+          <a:lstStyle/>
+          <a:p>
+            <a:endParaRPr lang="en-US"/>
+          </a:p>
+        </p:txBody>
       </p:sp>
       <p:sp>
         <p:nvSpPr>
@@ -2740,7 +2594,7 @@
           <a:bodyPr wrap="square" lIns="0" tIns="0" rIns="0" bIns="0" rtlCol="0" anchor="ctr"/>
           <a:lstStyle/>
           <a:p>
-            <a:pPr algn="ctr" indent="0" marL="0">
+            <a:pPr marL="0" indent="0" algn="ctr">
               <a:buNone/>
             </a:pPr>
             <a:r>
@@ -2779,7 +2633,7 @@
           <a:bodyPr wrap="square" lIns="0" tIns="0" rIns="0" bIns="0" rtlCol="0" anchor="ctr"/>
           <a:lstStyle/>
           <a:p>
-            <a:pPr indent="0" marL="0">
+            <a:pPr marL="0" indent="0">
               <a:buNone/>
             </a:pPr>
             <a:r>
@@ -2818,7 +2672,7 @@
           <a:bodyPr wrap="square" lIns="0" tIns="0" rIns="0" bIns="0" rtlCol="0" anchor="ctr"/>
           <a:lstStyle/>
           <a:p>
-            <a:pPr indent="0" marL="0">
+            <a:pPr marL="0" indent="0">
               <a:buNone/>
             </a:pPr>
             <a:r>
@@ -2857,6 +2711,13 @@
           </a:solidFill>
           <a:ln/>
         </p:spPr>
+        <p:txBody>
+          <a:bodyPr/>
+          <a:lstStyle/>
+          <a:p>
+            <a:endParaRPr lang="en-US"/>
+          </a:p>
+        </p:txBody>
       </p:sp>
       <p:sp>
         <p:nvSpPr>
@@ -2879,7 +2740,7 @@
           <a:bodyPr wrap="square" lIns="0" tIns="0" rIns="0" bIns="0" rtlCol="0" anchor="ctr"/>
           <a:lstStyle/>
           <a:p>
-            <a:pPr algn="ctr" indent="0" marL="0">
+            <a:pPr marL="0" indent="0" algn="ctr">
               <a:buNone/>
             </a:pPr>
             <a:r>
@@ -2918,7 +2779,7 @@
           <a:bodyPr wrap="square" lIns="0" tIns="0" rIns="0" bIns="0" rtlCol="0" anchor="ctr"/>
           <a:lstStyle/>
           <a:p>
-            <a:pPr indent="0" marL="0">
+            <a:pPr marL="0" indent="0">
               <a:buNone/>
             </a:pPr>
             <a:r>
@@ -2957,7 +2818,7 @@
           <a:bodyPr wrap="square" lIns="0" tIns="0" rIns="0" bIns="0" rtlCol="0" anchor="ctr"/>
           <a:lstStyle/>
           <a:p>
-            <a:pPr indent="0" marL="0">
+            <a:pPr marL="0" indent="0">
               <a:buNone/>
             </a:pPr>
             <a:r>
@@ -2996,6 +2857,13 @@
           </a:solidFill>
           <a:ln/>
         </p:spPr>
+        <p:txBody>
+          <a:bodyPr/>
+          <a:lstStyle/>
+          <a:p>
+            <a:endParaRPr lang="en-US"/>
+          </a:p>
+        </p:txBody>
       </p:sp>
       <p:sp>
         <p:nvSpPr>
@@ -3018,7 +2886,7 @@
           <a:bodyPr wrap="square" lIns="0" tIns="0" rIns="0" bIns="0" rtlCol="0" anchor="ctr"/>
           <a:lstStyle/>
           <a:p>
-            <a:pPr algn="ctr" indent="0" marL="0">
+            <a:pPr marL="0" indent="0" algn="ctr">
               <a:buNone/>
             </a:pPr>
             <a:r>
@@ -3057,7 +2925,7 @@
           <a:bodyPr wrap="square" lIns="0" tIns="0" rIns="0" bIns="0" rtlCol="0" anchor="ctr"/>
           <a:lstStyle/>
           <a:p>
-            <a:pPr indent="0" marL="0">
+            <a:pPr marL="0" indent="0">
               <a:buNone/>
             </a:pPr>
             <a:r>
@@ -3096,7 +2964,7 @@
           <a:bodyPr wrap="square" lIns="0" tIns="0" rIns="0" bIns="0" rtlCol="0" anchor="ctr"/>
           <a:lstStyle/>
           <a:p>
-            <a:pPr indent="0" marL="0">
+            <a:pPr marL="0" indent="0">
               <a:buNone/>
             </a:pPr>
             <a:r>
@@ -3130,6 +2998,7 @@
         <a:solidFill>
           <a:srgbClr val="F7F8FB"/>
         </a:solidFill>
+        <a:effectLst/>
       </p:bgPr>
     </p:bg>
     <p:spTree>
@@ -3167,11 +3036,11 @@
           <a:bodyPr wrap="square" lIns="0" tIns="0" rIns="0" bIns="0" rtlCol="0" anchor="ctr"/>
           <a:lstStyle/>
           <a:p>
-            <a:pPr indent="0" marL="0">
-              <a:buNone/>
-            </a:pPr>
-            <a:r>
-              <a:rPr lang="en-US" sz="1200" b="1" spc="200" kern="0" dirty="0">
+            <a:pPr marL="0" indent="0">
+              <a:buNone/>
+            </a:pPr>
+            <a:r>
+              <a:rPr lang="en-US" sz="1200" b="1" kern="0" spc="200" dirty="0">
                 <a:solidFill>
                   <a:srgbClr val="FF9900"/>
                 </a:solidFill>
@@ -3206,7 +3075,7 @@
           <a:bodyPr wrap="square" lIns="0" tIns="0" rIns="0" bIns="0" rtlCol="0" anchor="ctr"/>
           <a:lstStyle/>
           <a:p>
-            <a:pPr indent="0" marL="0">
+            <a:pPr marL="0" indent="0">
               <a:buNone/>
             </a:pPr>
             <a:r>
@@ -3250,13 +3119,20 @@
             <a:prstDash val="solid"/>
           </a:ln>
           <a:effectLst>
-            <a:outerShdw sx="100000" sy="100000" kx="0" ky="0" algn="bl" rotWithShape="0" blurRad="76200" dist="38100" dir="5400000">
+            <a:outerShdw blurRad="76200" dist="38100" dir="5400000" algn="bl" rotWithShape="0">
               <a:srgbClr val="000000">
                 <a:alpha val="12000"/>
               </a:srgbClr>
             </a:outerShdw>
           </a:effectLst>
         </p:spPr>
+        <p:txBody>
+          <a:bodyPr/>
+          <a:lstStyle/>
+          <a:p>
+            <a:endParaRPr lang="en-US"/>
+          </a:p>
+        </p:txBody>
       </p:sp>
       <p:sp>
         <p:nvSpPr>
@@ -3279,7 +3155,7 @@
           <a:bodyPr wrap="square" lIns="0" tIns="0" rIns="0" bIns="0" rtlCol="0" anchor="ctr"/>
           <a:lstStyle/>
           <a:p>
-            <a:pPr algn="ctr" indent="0" marL="0">
+            <a:pPr marL="0" indent="0" algn="ctr">
               <a:buNone/>
             </a:pPr>
             <a:r>
@@ -3318,7 +3194,7 @@
           <a:bodyPr wrap="square" lIns="0" tIns="0" rIns="0" bIns="0" rtlCol="0" anchor="ctr"/>
           <a:lstStyle/>
           <a:p>
-            <a:pPr algn="ctr" indent="0" marL="0">
+            <a:pPr marL="0" indent="0" algn="ctr">
               <a:buNone/>
             </a:pPr>
             <a:r>
@@ -3355,6 +3231,13 @@
           </a:solidFill>
           <a:ln/>
         </p:spPr>
+        <p:txBody>
+          <a:bodyPr/>
+          <a:lstStyle/>
+          <a:p>
+            <a:endParaRPr lang="en-US"/>
+          </a:p>
+        </p:txBody>
       </p:sp>
       <p:sp>
         <p:nvSpPr>
@@ -3382,13 +3265,20 @@
             <a:prstDash val="solid"/>
           </a:ln>
           <a:effectLst>
-            <a:outerShdw sx="100000" sy="100000" kx="0" ky="0" algn="bl" rotWithShape="0" blurRad="76200" dist="38100" dir="5400000">
+            <a:outerShdw blurRad="76200" dist="38100" dir="5400000" algn="bl" rotWithShape="0">
               <a:srgbClr val="000000">
                 <a:alpha val="12000"/>
               </a:srgbClr>
             </a:outerShdw>
           </a:effectLst>
         </p:spPr>
+        <p:txBody>
+          <a:bodyPr/>
+          <a:lstStyle/>
+          <a:p>
+            <a:endParaRPr lang="en-US"/>
+          </a:p>
+        </p:txBody>
       </p:sp>
       <p:sp>
         <p:nvSpPr>
@@ -3411,7 +3301,7 @@
           <a:bodyPr wrap="square" lIns="0" tIns="0" rIns="0" bIns="0" rtlCol="0" anchor="ctr"/>
           <a:lstStyle/>
           <a:p>
-            <a:pPr algn="ctr" indent="0" marL="0">
+            <a:pPr marL="0" indent="0" algn="ctr">
               <a:buNone/>
             </a:pPr>
             <a:r>
@@ -3450,7 +3340,7 @@
           <a:bodyPr wrap="square" lIns="0" tIns="0" rIns="0" bIns="0" rtlCol="0" anchor="ctr"/>
           <a:lstStyle/>
           <a:p>
-            <a:pPr algn="ctr" indent="0" marL="0">
+            <a:pPr marL="0" indent="0" algn="ctr">
               <a:buNone/>
             </a:pPr>
             <a:r>
@@ -3487,6 +3377,13 @@
           </a:solidFill>
           <a:ln/>
         </p:spPr>
+        <p:txBody>
+          <a:bodyPr/>
+          <a:lstStyle/>
+          <a:p>
+            <a:endParaRPr lang="en-US"/>
+          </a:p>
+        </p:txBody>
       </p:sp>
       <p:sp>
         <p:nvSpPr>
@@ -3514,13 +3411,20 @@
             <a:prstDash val="solid"/>
           </a:ln>
           <a:effectLst>
-            <a:outerShdw sx="100000" sy="100000" kx="0" ky="0" algn="bl" rotWithShape="0" blurRad="76200" dist="38100" dir="5400000">
+            <a:outerShdw blurRad="76200" dist="38100" dir="5400000" algn="bl" rotWithShape="0">
               <a:srgbClr val="000000">
                 <a:alpha val="12000"/>
               </a:srgbClr>
             </a:outerShdw>
           </a:effectLst>
         </p:spPr>
+        <p:txBody>
+          <a:bodyPr/>
+          <a:lstStyle/>
+          <a:p>
+            <a:endParaRPr lang="en-US"/>
+          </a:p>
+        </p:txBody>
       </p:sp>
       <p:sp>
         <p:nvSpPr>
@@ -3543,7 +3447,7 @@
           <a:bodyPr wrap="square" lIns="0" tIns="0" rIns="0" bIns="0" rtlCol="0" anchor="ctr"/>
           <a:lstStyle/>
           <a:p>
-            <a:pPr algn="ctr" indent="0" marL="0">
+            <a:pPr marL="0" indent="0" algn="ctr">
               <a:buNone/>
             </a:pPr>
             <a:r>
@@ -3582,7 +3486,7 @@
           <a:bodyPr wrap="square" lIns="0" tIns="0" rIns="0" bIns="0" rtlCol="0" anchor="ctr"/>
           <a:lstStyle/>
           <a:p>
-            <a:pPr algn="ctr" indent="0" marL="0">
+            <a:pPr marL="0" indent="0" algn="ctr">
               <a:buNone/>
             </a:pPr>
             <a:r>
@@ -3619,6 +3523,13 @@
           </a:solidFill>
           <a:ln/>
         </p:spPr>
+        <p:txBody>
+          <a:bodyPr/>
+          <a:lstStyle/>
+          <a:p>
+            <a:endParaRPr lang="en-US"/>
+          </a:p>
+        </p:txBody>
       </p:sp>
       <p:sp>
         <p:nvSpPr>
@@ -3646,13 +3557,20 @@
             <a:prstDash val="solid"/>
           </a:ln>
           <a:effectLst>
-            <a:outerShdw sx="100000" sy="100000" kx="0" ky="0" algn="bl" rotWithShape="0" blurRad="76200" dist="38100" dir="5400000">
+            <a:outerShdw blurRad="76200" dist="38100" dir="5400000" algn="bl" rotWithShape="0">
               <a:srgbClr val="000000">
                 <a:alpha val="12000"/>
               </a:srgbClr>
             </a:outerShdw>
           </a:effectLst>
         </p:spPr>
+        <p:txBody>
+          <a:bodyPr/>
+          <a:lstStyle/>
+          <a:p>
+            <a:endParaRPr lang="en-US"/>
+          </a:p>
+        </p:txBody>
       </p:sp>
       <p:sp>
         <p:nvSpPr>
@@ -3675,7 +3593,7 @@
           <a:bodyPr wrap="square" lIns="0" tIns="0" rIns="0" bIns="0" rtlCol="0" anchor="ctr"/>
           <a:lstStyle/>
           <a:p>
-            <a:pPr algn="ctr" indent="0" marL="0">
+            <a:pPr marL="0" indent="0" algn="ctr">
               <a:buNone/>
             </a:pPr>
             <a:r>
@@ -3714,7 +3632,7 @@
           <a:bodyPr wrap="square" lIns="0" tIns="0" rIns="0" bIns="0" rtlCol="0" anchor="ctr"/>
           <a:lstStyle/>
           <a:p>
-            <a:pPr algn="ctr" indent="0" marL="0">
+            <a:pPr marL="0" indent="0" algn="ctr">
               <a:buNone/>
             </a:pPr>
             <a:r>
@@ -3753,7 +3671,7 @@
           <a:bodyPr wrap="square" lIns="0" tIns="0" rIns="0" bIns="0" rtlCol="0" anchor="ctr"/>
           <a:lstStyle/>
           <a:p>
-            <a:pPr indent="0" marL="0">
+            <a:pPr marL="0" indent="0">
               <a:buNone/>
             </a:pPr>
             <a:r>
@@ -3794,7 +3712,7 @@
           <a:bodyPr wrap="square" lIns="101600" tIns="101600" rIns="101600" bIns="101600" rtlCol="0" anchor="ctr"/>
           <a:lstStyle/>
           <a:p>
-            <a:pPr indent="0" marL="0">
+            <a:pPr marL="0" indent="0">
               <a:buNone/>
             </a:pPr>
             <a:r>
@@ -3828,6 +3746,7 @@
         <a:solidFill>
           <a:srgbClr val="F7F8FB"/>
         </a:solidFill>
+        <a:effectLst/>
       </p:bgPr>
     </p:bg>
     <p:spTree>
@@ -3865,11 +3784,11 @@
           <a:bodyPr wrap="square" lIns="0" tIns="0" rIns="0" bIns="0" rtlCol="0" anchor="ctr"/>
           <a:lstStyle/>
           <a:p>
-            <a:pPr indent="0" marL="0">
-              <a:buNone/>
-            </a:pPr>
-            <a:r>
-              <a:rPr lang="en-US" sz="1200" b="1" spc="200" kern="0" dirty="0">
+            <a:pPr marL="0" indent="0">
+              <a:buNone/>
+            </a:pPr>
+            <a:r>
+              <a:rPr lang="en-US" sz="1200" b="1" kern="0" spc="200" dirty="0">
                 <a:solidFill>
                   <a:srgbClr val="FF9900"/>
                 </a:solidFill>
@@ -3904,7 +3823,7 @@
           <a:bodyPr wrap="square" lIns="0" tIns="0" rIns="0" bIns="0" rtlCol="0" anchor="ctr"/>
           <a:lstStyle/>
           <a:p>
-            <a:pPr indent="0" marL="0">
+            <a:pPr marL="0" indent="0">
               <a:buNone/>
             </a:pPr>
             <a:r>
@@ -3941,6 +3860,13 @@
           </a:solidFill>
           <a:ln/>
         </p:spPr>
+        <p:txBody>
+          <a:bodyPr/>
+          <a:lstStyle/>
+          <a:p>
+            <a:endParaRPr lang="en-US"/>
+          </a:p>
+        </p:txBody>
       </p:sp>
       <p:sp>
         <p:nvSpPr>
@@ -3963,7 +3889,7 @@
           <a:bodyPr wrap="square" lIns="0" tIns="0" rIns="0" bIns="0" rtlCol="0" anchor="ctr"/>
           <a:lstStyle/>
           <a:p>
-            <a:pPr indent="0" marL="0">
+            <a:pPr marL="0" indent="0">
               <a:buNone/>
             </a:pPr>
             <a:r>
@@ -4002,7 +3928,7 @@
           <a:bodyPr wrap="square" lIns="0" tIns="0" rIns="0" bIns="0" rtlCol="0" anchor="ctr"/>
           <a:lstStyle/>
           <a:p>
-            <a:pPr indent="0" marL="0">
+            <a:pPr marL="0" indent="0">
               <a:buNone/>
             </a:pPr>
             <a:r>
@@ -4041,7 +3967,7 @@
           <a:bodyPr wrap="square" lIns="0" tIns="0" rIns="0" bIns="0" rtlCol="0" anchor="ctr"/>
           <a:lstStyle/>
           <a:p>
-            <a:pPr indent="0" marL="0">
+            <a:pPr marL="0" indent="0">
               <a:buNone/>
             </a:pPr>
             <a:r>
@@ -4080,7 +4006,7 @@
           <a:bodyPr wrap="square" lIns="0" tIns="0" rIns="0" bIns="0" rtlCol="0" anchor="ctr"/>
           <a:lstStyle/>
           <a:p>
-            <a:pPr indent="0" marL="0">
+            <a:pPr marL="0" indent="0">
               <a:buNone/>
             </a:pPr>
             <a:r>
@@ -4117,6 +4043,13 @@
           </a:solidFill>
           <a:ln/>
         </p:spPr>
+        <p:txBody>
+          <a:bodyPr/>
+          <a:lstStyle/>
+          <a:p>
+            <a:endParaRPr lang="en-US"/>
+          </a:p>
+        </p:txBody>
       </p:sp>
       <p:sp>
         <p:nvSpPr>
@@ -4139,7 +4072,7 @@
           <a:bodyPr wrap="square" lIns="0" tIns="0" rIns="0" bIns="0" rtlCol="0" anchor="ctr"/>
           <a:lstStyle/>
           <a:p>
-            <a:pPr indent="0" marL="0">
+            <a:pPr marL="0" indent="0">
               <a:buNone/>
             </a:pPr>
             <a:r>
@@ -4178,7 +4111,7 @@
           <a:bodyPr wrap="square" lIns="0" tIns="0" rIns="0" bIns="0" rtlCol="0" anchor="ctr"/>
           <a:lstStyle/>
           <a:p>
-            <a:pPr indent="0" marL="0">
+            <a:pPr marL="0" indent="0">
               <a:buNone/>
             </a:pPr>
             <a:r>
@@ -4217,7 +4150,7 @@
           <a:bodyPr wrap="square" lIns="0" tIns="0" rIns="0" bIns="0" rtlCol="0" anchor="ctr"/>
           <a:lstStyle/>
           <a:p>
-            <a:pPr indent="0" marL="0">
+            <a:pPr marL="0" indent="0">
               <a:buNone/>
             </a:pPr>
             <a:r>
@@ -4256,7 +4189,7 @@
           <a:bodyPr wrap="square" lIns="0" tIns="0" rIns="0" bIns="0" rtlCol="0" anchor="ctr"/>
           <a:lstStyle/>
           <a:p>
-            <a:pPr indent="0" marL="0">
+            <a:pPr marL="0" indent="0">
               <a:buNone/>
             </a:pPr>
             <a:r>
@@ -4293,6 +4226,13 @@
           </a:solidFill>
           <a:ln/>
         </p:spPr>
+        <p:txBody>
+          <a:bodyPr/>
+          <a:lstStyle/>
+          <a:p>
+            <a:endParaRPr lang="en-US"/>
+          </a:p>
+        </p:txBody>
       </p:sp>
       <p:sp>
         <p:nvSpPr>
@@ -4315,7 +4255,7 @@
           <a:bodyPr wrap="square" lIns="0" tIns="0" rIns="0" bIns="0" rtlCol="0" anchor="ctr"/>
           <a:lstStyle/>
           <a:p>
-            <a:pPr indent="0" marL="0">
+            <a:pPr marL="0" indent="0">
               <a:buNone/>
             </a:pPr>
             <a:r>
@@ -4354,7 +4294,7 @@
           <a:bodyPr wrap="square" lIns="0" tIns="0" rIns="0" bIns="0" rtlCol="0" anchor="ctr"/>
           <a:lstStyle/>
           <a:p>
-            <a:pPr indent="0" marL="0">
+            <a:pPr marL="0" indent="0">
               <a:buNone/>
             </a:pPr>
             <a:r>
@@ -4393,7 +4333,7 @@
           <a:bodyPr wrap="square" lIns="0" tIns="0" rIns="0" bIns="0" rtlCol="0" anchor="ctr"/>
           <a:lstStyle/>
           <a:p>
-            <a:pPr indent="0" marL="0">
+            <a:pPr marL="0" indent="0">
               <a:buNone/>
             </a:pPr>
             <a:r>
@@ -4432,7 +4372,7 @@
           <a:bodyPr wrap="square" lIns="0" tIns="0" rIns="0" bIns="0" rtlCol="0" anchor="ctr"/>
           <a:lstStyle/>
           <a:p>
-            <a:pPr indent="0" marL="0">
+            <a:pPr marL="0" indent="0">
               <a:buNone/>
             </a:pPr>
             <a:r>
@@ -4466,6 +4406,7 @@
         <a:solidFill>
           <a:srgbClr val="F7F8FB"/>
         </a:solidFill>
+        <a:effectLst/>
       </p:bgPr>
     </p:bg>
     <p:spTree>
@@ -4503,11 +4444,11 @@
           <a:bodyPr wrap="square" lIns="0" tIns="0" rIns="0" bIns="0" rtlCol="0" anchor="ctr"/>
           <a:lstStyle/>
           <a:p>
-            <a:pPr indent="0" marL="0">
-              <a:buNone/>
-            </a:pPr>
-            <a:r>
-              <a:rPr lang="en-US" sz="1200" b="1" spc="200" kern="0" dirty="0">
+            <a:pPr marL="0" indent="0">
+              <a:buNone/>
+            </a:pPr>
+            <a:r>
+              <a:rPr lang="en-US" sz="1200" b="1" kern="0" spc="200" dirty="0">
                 <a:solidFill>
                   <a:srgbClr val="FF9900"/>
                 </a:solidFill>
@@ -4542,7 +4483,7 @@
           <a:bodyPr wrap="square" lIns="0" tIns="0" rIns="0" bIns="0" rtlCol="0" anchor="ctr"/>
           <a:lstStyle/>
           <a:p>
-            <a:pPr indent="0" marL="0">
+            <a:pPr marL="0" indent="0">
               <a:buNone/>
             </a:pPr>
             <a:r>
@@ -4581,7 +4522,7 @@
           <a:bodyPr wrap="square" lIns="0" tIns="0" rIns="0" bIns="0" rtlCol="0" anchor="ctr"/>
           <a:lstStyle/>
           <a:p>
-            <a:pPr indent="0" marL="0">
+            <a:pPr marL="0" indent="0">
               <a:buNone/>
             </a:pPr>
             <a:r>
@@ -4620,7 +4561,7 @@
           <a:bodyPr wrap="square" lIns="0" tIns="0" rIns="0" bIns="0" rtlCol="0" anchor="ctr"/>
           <a:lstStyle/>
           <a:p>
-            <a:pPr indent="0" marL="0">
+            <a:pPr marL="0" indent="0">
               <a:buNone/>
             </a:pPr>
             <a:r>
@@ -4659,7 +4600,7 @@
           <a:bodyPr wrap="square" lIns="0" tIns="0" rIns="0" bIns="0" rtlCol="0" anchor="ctr"/>
           <a:lstStyle/>
           <a:p>
-            <a:pPr indent="0" marL="0">
+            <a:pPr marL="0" indent="0">
               <a:buNone/>
             </a:pPr>
             <a:r>
@@ -4699,6 +4640,13 @@
             <a:prstDash val="solid"/>
           </a:ln>
         </p:spPr>
+        <p:txBody>
+          <a:bodyPr/>
+          <a:lstStyle/>
+          <a:p>
+            <a:endParaRPr lang="en-US"/>
+          </a:p>
+        </p:txBody>
       </p:sp>
       <p:sp>
         <p:nvSpPr>
@@ -4723,6 +4671,13 @@
           </a:solidFill>
           <a:ln/>
         </p:spPr>
+        <p:txBody>
+          <a:bodyPr/>
+          <a:lstStyle/>
+          <a:p>
+            <a:endParaRPr lang="en-US"/>
+          </a:p>
+        </p:txBody>
       </p:sp>
       <p:sp>
         <p:nvSpPr>
@@ -4745,7 +4700,7 @@
           <a:bodyPr wrap="square" lIns="0" tIns="0" rIns="0" bIns="0" rtlCol="0" anchor="ctr"/>
           <a:lstStyle/>
           <a:p>
-            <a:pPr algn="ctr" indent="0" marL="0">
+            <a:pPr marL="0" indent="0" algn="ctr">
               <a:buNone/>
             </a:pPr>
             <a:r>
@@ -4784,7 +4739,7 @@
           <a:bodyPr wrap="square" lIns="0" tIns="0" rIns="0" bIns="0" rtlCol="0" anchor="ctr"/>
           <a:lstStyle/>
           <a:p>
-            <a:pPr indent="0" marL="0">
+            <a:pPr marL="0" indent="0">
               <a:buNone/>
             </a:pPr>
             <a:r>
@@ -4823,7 +4778,7 @@
           <a:bodyPr wrap="square" lIns="0" tIns="0" rIns="0" bIns="0" rtlCol="0" anchor="ctr"/>
           <a:lstStyle/>
           <a:p>
-            <a:pPr indent="0" marL="0">
+            <a:pPr marL="0" indent="0">
               <a:buNone/>
             </a:pPr>
             <a:r>
@@ -4864,6 +4819,13 @@
           </a:solidFill>
           <a:ln/>
         </p:spPr>
+        <p:txBody>
+          <a:bodyPr/>
+          <a:lstStyle/>
+          <a:p>
+            <a:endParaRPr lang="en-US"/>
+          </a:p>
+        </p:txBody>
       </p:sp>
       <p:sp>
         <p:nvSpPr>
@@ -4886,7 +4848,7 @@
           <a:bodyPr wrap="square" lIns="0" tIns="0" rIns="0" bIns="0" rtlCol="0" anchor="ctr"/>
           <a:lstStyle/>
           <a:p>
-            <a:pPr algn="ctr" indent="0" marL="0">
+            <a:pPr marL="0" indent="0" algn="ctr">
               <a:buNone/>
             </a:pPr>
             <a:r>
@@ -4925,7 +4887,7 @@
           <a:bodyPr wrap="square" lIns="0" tIns="0" rIns="0" bIns="0" rtlCol="0" anchor="ctr"/>
           <a:lstStyle/>
           <a:p>
-            <a:pPr indent="0" marL="0">
+            <a:pPr marL="0" indent="0">
               <a:buNone/>
             </a:pPr>
             <a:r>
@@ -4964,7 +4926,7 @@
           <a:bodyPr wrap="square" lIns="0" tIns="0" rIns="0" bIns="0" rtlCol="0" anchor="ctr"/>
           <a:lstStyle/>
           <a:p>
-            <a:pPr indent="0" marL="0">
+            <a:pPr marL="0" indent="0">
               <a:buNone/>
             </a:pPr>
             <a:r>
@@ -5005,6 +4967,13 @@
           </a:solidFill>
           <a:ln/>
         </p:spPr>
+        <p:txBody>
+          <a:bodyPr/>
+          <a:lstStyle/>
+          <a:p>
+            <a:endParaRPr lang="en-US"/>
+          </a:p>
+        </p:txBody>
       </p:sp>
       <p:sp>
         <p:nvSpPr>
@@ -5027,7 +4996,7 @@
           <a:bodyPr wrap="square" lIns="0" tIns="0" rIns="0" bIns="0" rtlCol="0" anchor="ctr"/>
           <a:lstStyle/>
           <a:p>
-            <a:pPr algn="ctr" indent="0" marL="0">
+            <a:pPr marL="0" indent="0" algn="ctr">
               <a:buNone/>
             </a:pPr>
             <a:r>
@@ -5066,7 +5035,7 @@
           <a:bodyPr wrap="square" lIns="0" tIns="0" rIns="0" bIns="0" rtlCol="0" anchor="ctr"/>
           <a:lstStyle/>
           <a:p>
-            <a:pPr indent="0" marL="0">
+            <a:pPr marL="0" indent="0">
               <a:buNone/>
             </a:pPr>
             <a:r>
@@ -5105,7 +5074,7 @@
           <a:bodyPr wrap="square" lIns="0" tIns="0" rIns="0" bIns="0" rtlCol="0" anchor="ctr"/>
           <a:lstStyle/>
           <a:p>
-            <a:pPr indent="0" marL="0">
+            <a:pPr marL="0" indent="0">
               <a:buNone/>
             </a:pPr>
             <a:r>
@@ -5146,6 +5115,13 @@
           </a:solidFill>
           <a:ln/>
         </p:spPr>
+        <p:txBody>
+          <a:bodyPr/>
+          <a:lstStyle/>
+          <a:p>
+            <a:endParaRPr lang="en-US"/>
+          </a:p>
+        </p:txBody>
       </p:sp>
       <p:sp>
         <p:nvSpPr>
@@ -5168,7 +5144,7 @@
           <a:bodyPr wrap="square" lIns="0" tIns="0" rIns="0" bIns="0" rtlCol="0" anchor="ctr"/>
           <a:lstStyle/>
           <a:p>
-            <a:pPr algn="ctr" indent="0" marL="0">
+            <a:pPr marL="0" indent="0" algn="ctr">
               <a:buNone/>
             </a:pPr>
             <a:r>
@@ -5207,7 +5183,7 @@
           <a:bodyPr wrap="square" lIns="0" tIns="0" rIns="0" bIns="0" rtlCol="0" anchor="ctr"/>
           <a:lstStyle/>
           <a:p>
-            <a:pPr indent="0" marL="0">
+            <a:pPr marL="0" indent="0">
               <a:buNone/>
             </a:pPr>
             <a:r>
@@ -5246,7 +5222,7 @@
           <a:bodyPr wrap="square" lIns="0" tIns="0" rIns="0" bIns="0" rtlCol="0" anchor="ctr"/>
           <a:lstStyle/>
           <a:p>
-            <a:pPr indent="0" marL="0">
+            <a:pPr marL="0" indent="0">
               <a:buNone/>
             </a:pPr>
             <a:r>
@@ -5287,6 +5263,13 @@
           </a:solidFill>
           <a:ln/>
         </p:spPr>
+        <p:txBody>
+          <a:bodyPr/>
+          <a:lstStyle/>
+          <a:p>
+            <a:endParaRPr lang="en-US"/>
+          </a:p>
+        </p:txBody>
       </p:sp>
       <p:sp>
         <p:nvSpPr>
@@ -5309,7 +5292,7 @@
           <a:bodyPr wrap="square" lIns="0" tIns="0" rIns="0" bIns="0" rtlCol="0" anchor="ctr"/>
           <a:lstStyle/>
           <a:p>
-            <a:pPr algn="ctr" indent="0" marL="0">
+            <a:pPr marL="0" indent="0" algn="ctr">
               <a:buNone/>
             </a:pPr>
             <a:r>
@@ -5348,7 +5331,7 @@
           <a:bodyPr wrap="square" lIns="0" tIns="0" rIns="0" bIns="0" rtlCol="0" anchor="ctr"/>
           <a:lstStyle/>
           <a:p>
-            <a:pPr indent="0" marL="0">
+            <a:pPr marL="0" indent="0">
               <a:buNone/>
             </a:pPr>
             <a:r>
@@ -5387,7 +5370,7 @@
           <a:bodyPr wrap="square" lIns="0" tIns="0" rIns="0" bIns="0" rtlCol="0" anchor="ctr"/>
           <a:lstStyle/>
           <a:p>
-            <a:pPr indent="0" marL="0">
+            <a:pPr marL="0" indent="0">
               <a:buNone/>
             </a:pPr>
             <a:r>
@@ -5421,6 +5404,7 @@
         <a:solidFill>
           <a:srgbClr val="F7F8FB"/>
         </a:solidFill>
+        <a:effectLst/>
       </p:bgPr>
     </p:bg>
     <p:spTree>
@@ -5458,11 +5442,11 @@
           <a:bodyPr wrap="square" lIns="0" tIns="0" rIns="0" bIns="0" rtlCol="0" anchor="ctr"/>
           <a:lstStyle/>
           <a:p>
-            <a:pPr indent="0" marL="0">
-              <a:buNone/>
-            </a:pPr>
-            <a:r>
-              <a:rPr lang="en-US" sz="1200" b="1" spc="200" kern="0" dirty="0">
+            <a:pPr marL="0" indent="0">
+              <a:buNone/>
+            </a:pPr>
+            <a:r>
+              <a:rPr lang="en-US" sz="1200" b="1" kern="0" spc="200" dirty="0">
                 <a:solidFill>
                   <a:srgbClr val="FF9900"/>
                 </a:solidFill>
@@ -5497,7 +5481,7 @@
           <a:bodyPr wrap="square" lIns="0" tIns="0" rIns="0" bIns="0" rtlCol="0" anchor="ctr"/>
           <a:lstStyle/>
           <a:p>
-            <a:pPr indent="0" marL="0">
+            <a:pPr marL="0" indent="0">
               <a:buNone/>
             </a:pPr>
             <a:r>
@@ -5536,6 +5520,13 @@
           </a:solidFill>
           <a:ln/>
         </p:spPr>
+        <p:txBody>
+          <a:bodyPr/>
+          <a:lstStyle/>
+          <a:p>
+            <a:endParaRPr lang="en-US"/>
+          </a:p>
+        </p:txBody>
       </p:sp>
       <p:sp>
         <p:nvSpPr>
@@ -5558,7 +5549,7 @@
           <a:bodyPr wrap="square" lIns="0" tIns="0" rIns="0" bIns="0" rtlCol="0" anchor="ctr"/>
           <a:lstStyle/>
           <a:p>
-            <a:pPr algn="ctr" indent="0" marL="0">
+            <a:pPr marL="0" indent="0" algn="ctr">
               <a:buNone/>
             </a:pPr>
             <a:r>
@@ -5597,7 +5588,7 @@
           <a:bodyPr wrap="square" lIns="0" tIns="0" rIns="0" bIns="0" rtlCol="0" anchor="ctr"/>
           <a:lstStyle/>
           <a:p>
-            <a:pPr indent="0" marL="0">
+            <a:pPr marL="0" indent="0">
               <a:buNone/>
             </a:pPr>
             <a:r>
@@ -5636,7 +5627,7 @@
           <a:bodyPr wrap="square" lIns="0" tIns="0" rIns="0" bIns="0" rtlCol="0" anchor="ctr"/>
           <a:lstStyle/>
           <a:p>
-            <a:pPr indent="0" marL="0">
+            <a:pPr marL="0" indent="0">
               <a:buNone/>
             </a:pPr>
             <a:r>
@@ -5675,6 +5666,13 @@
           </a:solidFill>
           <a:ln/>
         </p:spPr>
+        <p:txBody>
+          <a:bodyPr/>
+          <a:lstStyle/>
+          <a:p>
+            <a:endParaRPr lang="en-US"/>
+          </a:p>
+        </p:txBody>
       </p:sp>
       <p:sp>
         <p:nvSpPr>
@@ -5697,7 +5695,7 @@
           <a:bodyPr wrap="square" lIns="0" tIns="0" rIns="0" bIns="0" rtlCol="0" anchor="ctr"/>
           <a:lstStyle/>
           <a:p>
-            <a:pPr algn="ctr" indent="0" marL="0">
+            <a:pPr marL="0" indent="0" algn="ctr">
               <a:buNone/>
             </a:pPr>
             <a:r>
@@ -5736,7 +5734,7 @@
           <a:bodyPr wrap="square" lIns="0" tIns="0" rIns="0" bIns="0" rtlCol="0" anchor="ctr"/>
           <a:lstStyle/>
           <a:p>
-            <a:pPr indent="0" marL="0">
+            <a:pPr marL="0" indent="0">
               <a:buNone/>
             </a:pPr>
             <a:r>
@@ -5775,7 +5773,7 @@
           <a:bodyPr wrap="square" lIns="0" tIns="0" rIns="0" bIns="0" rtlCol="0" anchor="ctr"/>
           <a:lstStyle/>
           <a:p>
-            <a:pPr indent="0" marL="0">
+            <a:pPr marL="0" indent="0">
               <a:buNone/>
             </a:pPr>
             <a:r>
@@ -5814,6 +5812,13 @@
           </a:solidFill>
           <a:ln/>
         </p:spPr>
+        <p:txBody>
+          <a:bodyPr/>
+          <a:lstStyle/>
+          <a:p>
+            <a:endParaRPr lang="en-US"/>
+          </a:p>
+        </p:txBody>
       </p:sp>
       <p:sp>
         <p:nvSpPr>
@@ -5836,7 +5841,7 @@
           <a:bodyPr wrap="square" lIns="0" tIns="0" rIns="0" bIns="0" rtlCol="0" anchor="ctr"/>
           <a:lstStyle/>
           <a:p>
-            <a:pPr algn="ctr" indent="0" marL="0">
+            <a:pPr marL="0" indent="0" algn="ctr">
               <a:buNone/>
             </a:pPr>
             <a:r>
@@ -5875,7 +5880,7 @@
           <a:bodyPr wrap="square" lIns="0" tIns="0" rIns="0" bIns="0" rtlCol="0" anchor="ctr"/>
           <a:lstStyle/>
           <a:p>
-            <a:pPr indent="0" marL="0">
+            <a:pPr marL="0" indent="0">
               <a:buNone/>
             </a:pPr>
             <a:r>
@@ -5914,7 +5919,7 @@
           <a:bodyPr wrap="square" lIns="0" tIns="0" rIns="0" bIns="0" rtlCol="0" anchor="ctr"/>
           <a:lstStyle/>
           <a:p>
-            <a:pPr indent="0" marL="0">
+            <a:pPr marL="0" indent="0">
               <a:buNone/>
             </a:pPr>
             <a:r>
@@ -5948,6 +5953,7 @@
         <a:solidFill>
           <a:srgbClr val="F7F8FB"/>
         </a:solidFill>
+        <a:effectLst/>
       </p:bgPr>
     </p:bg>
     <p:spTree>
@@ -5985,11 +5991,11 @@
           <a:bodyPr wrap="square" lIns="0" tIns="0" rIns="0" bIns="0" rtlCol="0" anchor="ctr"/>
           <a:lstStyle/>
           <a:p>
-            <a:pPr indent="0" marL="0">
-              <a:buNone/>
-            </a:pPr>
-            <a:r>
-              <a:rPr lang="en-US" sz="1200" b="1" spc="200" kern="0" dirty="0">
+            <a:pPr marL="0" indent="0">
+              <a:buNone/>
+            </a:pPr>
+            <a:r>
+              <a:rPr lang="en-US" sz="1200" b="1" kern="0" spc="200" dirty="0">
                 <a:solidFill>
                   <a:srgbClr val="FF9900"/>
                 </a:solidFill>
@@ -6024,7 +6030,7 @@
           <a:bodyPr wrap="square" lIns="0" tIns="0" rIns="0" bIns="0" rtlCol="0" anchor="ctr"/>
           <a:lstStyle/>
           <a:p>
-            <a:pPr indent="0" marL="0">
+            <a:pPr marL="0" indent="0">
               <a:buNone/>
             </a:pPr>
             <a:r>
@@ -6063,13 +6069,20 @@
           </a:solidFill>
           <a:ln/>
           <a:effectLst>
-            <a:outerShdw sx="100000" sy="100000" kx="0" ky="0" algn="bl" rotWithShape="0" blurRad="101600" dist="38100" dir="5400000">
+            <a:outerShdw blurRad="101600" dist="38100" dir="5400000" algn="bl" rotWithShape="0">
               <a:srgbClr val="000000">
                 <a:alpha val="10000"/>
               </a:srgbClr>
             </a:outerShdw>
           </a:effectLst>
         </p:spPr>
+        <p:txBody>
+          <a:bodyPr/>
+          <a:lstStyle/>
+          <a:p>
+            <a:endParaRPr lang="en-US"/>
+          </a:p>
+        </p:txBody>
       </p:sp>
       <p:sp>
         <p:nvSpPr>
@@ -6092,7 +6105,7 @@
           <a:bodyPr wrap="square" lIns="0" tIns="0" rIns="0" bIns="0" rtlCol="0" anchor="ctr"/>
           <a:lstStyle/>
           <a:p>
-            <a:pPr algn="ctr" indent="0" marL="0">
+            <a:pPr marL="0" indent="0" algn="ctr">
               <a:buNone/>
             </a:pPr>
             <a:r>
@@ -6131,7 +6144,7 @@
           <a:bodyPr wrap="square" lIns="0" tIns="0" rIns="0" bIns="0" rtlCol="0" anchor="ctr"/>
           <a:lstStyle/>
           <a:p>
-            <a:pPr algn="ctr" indent="0" marL="0">
+            <a:pPr marL="0" indent="0" algn="ctr">
               <a:buNone/>
             </a:pPr>
             <a:r>
@@ -6170,7 +6183,7 @@
           <a:bodyPr wrap="square" lIns="0" tIns="0" rIns="0" bIns="0" rtlCol="0" anchor="ctr"/>
           <a:lstStyle/>
           <a:p>
-            <a:pPr algn="ctr" indent="0" marL="0">
+            <a:pPr marL="0" indent="0" algn="ctr">
               <a:buNone/>
             </a:pPr>
             <a:r>
@@ -6209,13 +6222,20 @@
           </a:solidFill>
           <a:ln/>
           <a:effectLst>
-            <a:outerShdw sx="100000" sy="100000" kx="0" ky="0" algn="bl" rotWithShape="0" blurRad="101600" dist="38100" dir="5400000">
+            <a:outerShdw blurRad="101600" dist="38100" dir="5400000" algn="bl" rotWithShape="0">
               <a:srgbClr val="000000">
                 <a:alpha val="10000"/>
               </a:srgbClr>
             </a:outerShdw>
           </a:effectLst>
         </p:spPr>
+        <p:txBody>
+          <a:bodyPr/>
+          <a:lstStyle/>
+          <a:p>
+            <a:endParaRPr lang="en-US"/>
+          </a:p>
+        </p:txBody>
       </p:sp>
       <p:sp>
         <p:nvSpPr>
@@ -6238,7 +6258,7 @@
           <a:bodyPr wrap="square" lIns="0" tIns="0" rIns="0" bIns="0" rtlCol="0" anchor="ctr"/>
           <a:lstStyle/>
           <a:p>
-            <a:pPr algn="ctr" indent="0" marL="0">
+            <a:pPr marL="0" indent="0" algn="ctr">
               <a:buNone/>
             </a:pPr>
             <a:r>
@@ -6277,7 +6297,7 @@
           <a:bodyPr wrap="square" lIns="0" tIns="0" rIns="0" bIns="0" rtlCol="0" anchor="ctr"/>
           <a:lstStyle/>
           <a:p>
-            <a:pPr algn="ctr" indent="0" marL="0">
+            <a:pPr marL="0" indent="0" algn="ctr">
               <a:buNone/>
             </a:pPr>
             <a:r>
@@ -6316,7 +6336,7 @@
           <a:bodyPr wrap="square" lIns="0" tIns="0" rIns="0" bIns="0" rtlCol="0" anchor="ctr"/>
           <a:lstStyle/>
           <a:p>
-            <a:pPr algn="ctr" indent="0" marL="0">
+            <a:pPr marL="0" indent="0" algn="ctr">
               <a:buNone/>
             </a:pPr>
             <a:r>
@@ -6355,13 +6375,20 @@
           </a:solidFill>
           <a:ln/>
           <a:effectLst>
-            <a:outerShdw sx="100000" sy="100000" kx="0" ky="0" algn="bl" rotWithShape="0" blurRad="101600" dist="38100" dir="5400000">
+            <a:outerShdw blurRad="101600" dist="38100" dir="5400000" algn="bl" rotWithShape="0">
               <a:srgbClr val="000000">
                 <a:alpha val="10000"/>
               </a:srgbClr>
             </a:outerShdw>
           </a:effectLst>
         </p:spPr>
+        <p:txBody>
+          <a:bodyPr/>
+          <a:lstStyle/>
+          <a:p>
+            <a:endParaRPr lang="en-US"/>
+          </a:p>
+        </p:txBody>
       </p:sp>
       <p:sp>
         <p:nvSpPr>
@@ -6384,7 +6411,7 @@
           <a:bodyPr wrap="square" lIns="0" tIns="0" rIns="0" bIns="0" rtlCol="0" anchor="ctr"/>
           <a:lstStyle/>
           <a:p>
-            <a:pPr algn="ctr" indent="0" marL="0">
+            <a:pPr marL="0" indent="0" algn="ctr">
               <a:buNone/>
             </a:pPr>
             <a:r>
@@ -6423,7 +6450,7 @@
           <a:bodyPr wrap="square" lIns="0" tIns="0" rIns="0" bIns="0" rtlCol="0" anchor="ctr"/>
           <a:lstStyle/>
           <a:p>
-            <a:pPr algn="ctr" indent="0" marL="0">
+            <a:pPr marL="0" indent="0" algn="ctr">
               <a:buNone/>
             </a:pPr>
             <a:r>
@@ -6462,7 +6489,7 @@
           <a:bodyPr wrap="square" lIns="0" tIns="0" rIns="0" bIns="0" rtlCol="0" anchor="ctr"/>
           <a:lstStyle/>
           <a:p>
-            <a:pPr algn="ctr" indent="0" marL="0">
+            <a:pPr marL="0" indent="0" algn="ctr">
               <a:buNone/>
             </a:pPr>
             <a:r>
@@ -6501,7 +6528,7 @@
           <a:bodyPr wrap="square" lIns="0" tIns="0" rIns="0" bIns="0" rtlCol="0" anchor="ctr"/>
           <a:lstStyle/>
           <a:p>
-            <a:pPr indent="0" marL="0">
+            <a:pPr marL="0" indent="0">
               <a:buNone/>
             </a:pPr>
             <a:r>
@@ -6535,6 +6562,7 @@
         <a:solidFill>
           <a:srgbClr val="F7F8FB"/>
         </a:solidFill>
+        <a:effectLst/>
       </p:bgPr>
     </p:bg>
     <p:spTree>
@@ -6572,11 +6600,11 @@
           <a:bodyPr wrap="square" lIns="0" tIns="0" rIns="0" bIns="0" rtlCol="0" anchor="ctr"/>
           <a:lstStyle/>
           <a:p>
-            <a:pPr indent="0" marL="0">
-              <a:buNone/>
-            </a:pPr>
-            <a:r>
-              <a:rPr lang="en-US" sz="1200" b="1" spc="200" kern="0" dirty="0">
+            <a:pPr marL="0" indent="0">
+              <a:buNone/>
+            </a:pPr>
+            <a:r>
+              <a:rPr lang="en-US" sz="1200" b="1" kern="0" spc="200" dirty="0">
                 <a:solidFill>
                   <a:srgbClr val="FF9900"/>
                 </a:solidFill>
@@ -6611,7 +6639,7 @@
           <a:bodyPr wrap="square" lIns="0" tIns="0" rIns="0" bIns="0" rtlCol="0" anchor="ctr"/>
           <a:lstStyle/>
           <a:p>
-            <a:pPr indent="0" marL="0">
+            <a:pPr marL="0" indent="0">
               <a:buNone/>
             </a:pPr>
             <a:r>
@@ -6650,24 +6678,31 @@
           </a:solidFill>
           <a:ln/>
           <a:effectLst>
-            <a:outerShdw sx="100000" sy="100000" kx="0" ky="0" algn="bl" rotWithShape="0" blurRad="127000" dist="50800" dir="5400000">
+            <a:outerShdw blurRad="127000" dist="50800" dir="5400000" algn="bl" rotWithShape="0">
               <a:srgbClr val="000000">
                 <a:alpha val="18000"/>
               </a:srgbClr>
             </a:outerShdw>
           </a:effectLst>
         </p:spPr>
+        <p:txBody>
+          <a:bodyPr/>
+          <a:lstStyle/>
+          <a:p>
+            <a:endParaRPr lang="en-US"/>
+          </a:p>
+        </p:txBody>
       </p:sp>
       <p:pic>
         <p:nvPicPr>
-          <p:cNvPr id="5" name="Image 0" descr="/tmp/claude-chrome-screenshots-zhGCNJ/screenshot-1790448520480-0.jpg">    </p:cNvPr>
+          <p:cNvPr id="5" name="Image 0" descr="/tmp/claude-chrome-screenshots-zhGCNJ/screenshot-1790448520480-0.jpg"/>
           <p:cNvPicPr>
             <a:picLocks noChangeAspect="1"/>
           </p:cNvPicPr>
           <p:nvPr/>
         </p:nvPicPr>
         <p:blipFill>
-          <a:blip r:embed="rId1"/>
+          <a:blip r:embed="rId3"/>
           <a:stretch>
             <a:fillRect/>
           </a:stretch>
@@ -6703,6 +6738,13 @@
           </a:solidFill>
           <a:ln/>
         </p:spPr>
+        <p:txBody>
+          <a:bodyPr/>
+          <a:lstStyle/>
+          <a:p>
+            <a:endParaRPr lang="en-US"/>
+          </a:p>
+        </p:txBody>
       </p:sp>
       <p:sp>
         <p:nvSpPr>
@@ -6725,7 +6767,7 @@
           <a:bodyPr wrap="square" lIns="0" tIns="0" rIns="0" bIns="0" rtlCol="0" anchor="ctr"/>
           <a:lstStyle/>
           <a:p>
-            <a:pPr algn="ctr" indent="0" marL="0">
+            <a:pPr marL="0" indent="0" algn="ctr">
               <a:buNone/>
             </a:pPr>
             <a:r>
@@ -6764,7 +6806,7 @@
           <a:bodyPr wrap="square" lIns="0" tIns="0" rIns="0" bIns="0" rtlCol="0" anchor="ctr"/>
           <a:lstStyle/>
           <a:p>
-            <a:pPr indent="0" marL="0">
+            <a:pPr marL="0" indent="0">
               <a:buNone/>
             </a:pPr>
             <a:r>
@@ -6803,7 +6845,7 @@
           <a:bodyPr wrap="square" lIns="0" tIns="0" rIns="0" bIns="0" rtlCol="0" anchor="ctr"/>
           <a:lstStyle/>
           <a:p>
-            <a:pPr indent="0" marL="0">
+            <a:pPr marL="0" indent="0">
               <a:buNone/>
             </a:pPr>
             <a:r>
@@ -6842,6 +6884,13 @@
           </a:solidFill>
           <a:ln/>
         </p:spPr>
+        <p:txBody>
+          <a:bodyPr/>
+          <a:lstStyle/>
+          <a:p>
+            <a:endParaRPr lang="en-US"/>
+          </a:p>
+        </p:txBody>
       </p:sp>
       <p:sp>
         <p:nvSpPr>
@@ -6864,7 +6913,7 @@
           <a:bodyPr wrap="square" lIns="0" tIns="0" rIns="0" bIns="0" rtlCol="0" anchor="ctr"/>
           <a:lstStyle/>
           <a:p>
-            <a:pPr algn="ctr" indent="0" marL="0">
+            <a:pPr marL="0" indent="0" algn="ctr">
               <a:buNone/>
             </a:pPr>
             <a:r>
@@ -6903,7 +6952,7 @@
           <a:bodyPr wrap="square" lIns="0" tIns="0" rIns="0" bIns="0" rtlCol="0" anchor="ctr"/>
           <a:lstStyle/>
           <a:p>
-            <a:pPr indent="0" marL="0">
+            <a:pPr marL="0" indent="0">
               <a:buNone/>
             </a:pPr>
             <a:r>
@@ -6942,7 +6991,7 @@
           <a:bodyPr wrap="square" lIns="0" tIns="0" rIns="0" bIns="0" rtlCol="0" anchor="ctr"/>
           <a:lstStyle/>
           <a:p>
-            <a:pPr indent="0" marL="0">
+            <a:pPr marL="0" indent="0">
               <a:buNone/>
             </a:pPr>
             <a:r>
@@ -6981,6 +7030,13 @@
           </a:solidFill>
           <a:ln/>
         </p:spPr>
+        <p:txBody>
+          <a:bodyPr/>
+          <a:lstStyle/>
+          <a:p>
+            <a:endParaRPr lang="en-US"/>
+          </a:p>
+        </p:txBody>
       </p:sp>
       <p:sp>
         <p:nvSpPr>
@@ -7003,7 +7059,7 @@
           <a:bodyPr wrap="square" lIns="0" tIns="0" rIns="0" bIns="0" rtlCol="0" anchor="ctr"/>
           <a:lstStyle/>
           <a:p>
-            <a:pPr algn="ctr" indent="0" marL="0">
+            <a:pPr marL="0" indent="0" algn="ctr">
               <a:buNone/>
             </a:pPr>
             <a:r>
@@ -7042,7 +7098,7 @@
           <a:bodyPr wrap="square" lIns="0" tIns="0" rIns="0" bIns="0" rtlCol="0" anchor="ctr"/>
           <a:lstStyle/>
           <a:p>
-            <a:pPr indent="0" marL="0">
+            <a:pPr marL="0" indent="0">
               <a:buNone/>
             </a:pPr>
             <a:r>
@@ -7081,7 +7137,7 @@
           <a:bodyPr wrap="square" lIns="0" tIns="0" rIns="0" bIns="0" rtlCol="0" anchor="ctr"/>
           <a:lstStyle/>
           <a:p>
-            <a:pPr indent="0" marL="0">
+            <a:pPr marL="0" indent="0">
               <a:buNone/>
             </a:pPr>
             <a:r>
@@ -7115,6 +7171,7 @@
         <a:solidFill>
           <a:srgbClr val="F7F8FB"/>
         </a:solidFill>
+        <a:effectLst/>
       </p:bgPr>
     </p:bg>
     <p:spTree>
@@ -7152,11 +7209,11 @@
           <a:bodyPr wrap="square" lIns="0" tIns="0" rIns="0" bIns="0" rtlCol="0" anchor="ctr"/>
           <a:lstStyle/>
           <a:p>
-            <a:pPr indent="0" marL="0">
-              <a:buNone/>
-            </a:pPr>
-            <a:r>
-              <a:rPr lang="en-US" sz="1200" b="1" spc="200" kern="0" dirty="0">
+            <a:pPr marL="0" indent="0">
+              <a:buNone/>
+            </a:pPr>
+            <a:r>
+              <a:rPr lang="en-US" sz="1200" b="1" kern="0" spc="200" dirty="0">
                 <a:solidFill>
                   <a:srgbClr val="FF9900"/>
                 </a:solidFill>
@@ -7191,7 +7248,7 @@
           <a:bodyPr wrap="square" lIns="0" tIns="0" rIns="0" bIns="0" rtlCol="0" anchor="ctr"/>
           <a:lstStyle/>
           <a:p>
-            <a:pPr indent="0" marL="0">
+            <a:pPr marL="0" indent="0">
               <a:buNone/>
             </a:pPr>
             <a:r>
@@ -7230,6 +7287,13 @@
           </a:solidFill>
           <a:ln/>
         </p:spPr>
+        <p:txBody>
+          <a:bodyPr/>
+          <a:lstStyle/>
+          <a:p>
+            <a:endParaRPr lang="en-US"/>
+          </a:p>
+        </p:txBody>
       </p:sp>
       <p:sp>
         <p:nvSpPr>
@@ -7252,7 +7316,7 @@
           <a:bodyPr wrap="square" lIns="0" tIns="0" rIns="0" bIns="0" rtlCol="0" anchor="ctr"/>
           <a:lstStyle/>
           <a:p>
-            <a:pPr algn="ctr" indent="0" marL="0">
+            <a:pPr marL="0" indent="0" algn="ctr">
               <a:buNone/>
             </a:pPr>
             <a:r>
@@ -7291,7 +7355,7 @@
           <a:bodyPr wrap="square" lIns="0" tIns="0" rIns="0" bIns="0" rtlCol="0" anchor="ctr"/>
           <a:lstStyle/>
           <a:p>
-            <a:pPr indent="0" marL="0">
+            <a:pPr marL="0" indent="0">
               <a:buNone/>
             </a:pPr>
             <a:r>
@@ -7330,6 +7394,13 @@
           </a:solidFill>
           <a:ln/>
         </p:spPr>
+        <p:txBody>
+          <a:bodyPr/>
+          <a:lstStyle/>
+          <a:p>
+            <a:endParaRPr lang="en-US"/>
+          </a:p>
+        </p:txBody>
       </p:sp>
       <p:sp>
         <p:nvSpPr>
@@ -7352,7 +7423,7 @@
           <a:bodyPr wrap="square" lIns="0" tIns="0" rIns="0" bIns="0" rtlCol="0" anchor="ctr"/>
           <a:lstStyle/>
           <a:p>
-            <a:pPr algn="ctr" indent="0" marL="0">
+            <a:pPr marL="0" indent="0" algn="ctr">
               <a:buNone/>
             </a:pPr>
             <a:r>
@@ -7391,7 +7462,7 @@
           <a:bodyPr wrap="square" lIns="0" tIns="0" rIns="0" bIns="0" rtlCol="0" anchor="ctr"/>
           <a:lstStyle/>
           <a:p>
-            <a:pPr indent="0" marL="0">
+            <a:pPr marL="0" indent="0">
               <a:buNone/>
             </a:pPr>
             <a:r>
@@ -7430,6 +7501,13 @@
           </a:solidFill>
           <a:ln/>
         </p:spPr>
+        <p:txBody>
+          <a:bodyPr/>
+          <a:lstStyle/>
+          <a:p>
+            <a:endParaRPr lang="en-US"/>
+          </a:p>
+        </p:txBody>
       </p:sp>
       <p:sp>
         <p:nvSpPr>
@@ -7452,7 +7530,7 @@
           <a:bodyPr wrap="square" lIns="0" tIns="0" rIns="0" bIns="0" rtlCol="0" anchor="ctr"/>
           <a:lstStyle/>
           <a:p>
-            <a:pPr algn="ctr" indent="0" marL="0">
+            <a:pPr marL="0" indent="0" algn="ctr">
               <a:buNone/>
             </a:pPr>
             <a:r>
@@ -7491,7 +7569,7 @@
           <a:bodyPr wrap="square" lIns="0" tIns="0" rIns="0" bIns="0" rtlCol="0" anchor="ctr"/>
           <a:lstStyle/>
           <a:p>
-            <a:pPr indent="0" marL="0">
+            <a:pPr marL="0" indent="0">
               <a:buNone/>
             </a:pPr>
             <a:r>
@@ -7530,6 +7608,13 @@
           </a:solidFill>
           <a:ln/>
         </p:spPr>
+        <p:txBody>
+          <a:bodyPr/>
+          <a:lstStyle/>
+          <a:p>
+            <a:endParaRPr lang="en-US"/>
+          </a:p>
+        </p:txBody>
       </p:sp>
       <p:sp>
         <p:nvSpPr>
@@ -7552,7 +7637,7 @@
           <a:bodyPr wrap="square" lIns="0" tIns="0" rIns="0" bIns="0" rtlCol="0" anchor="ctr"/>
           <a:lstStyle/>
           <a:p>
-            <a:pPr algn="ctr" indent="0" marL="0">
+            <a:pPr marL="0" indent="0" algn="ctr">
               <a:buNone/>
             </a:pPr>
             <a:r>
@@ -7591,7 +7676,7 @@
           <a:bodyPr wrap="square" lIns="0" tIns="0" rIns="0" bIns="0" rtlCol="0" anchor="ctr"/>
           <a:lstStyle/>
           <a:p>
-            <a:pPr indent="0" marL="0">
+            <a:pPr marL="0" indent="0">
               <a:buNone/>
             </a:pPr>
             <a:r>
@@ -7630,6 +7715,13 @@
           </a:solidFill>
           <a:ln/>
         </p:spPr>
+        <p:txBody>
+          <a:bodyPr/>
+          <a:lstStyle/>
+          <a:p>
+            <a:endParaRPr lang="en-US"/>
+          </a:p>
+        </p:txBody>
       </p:sp>
       <p:sp>
         <p:nvSpPr>
@@ -7652,7 +7744,7 @@
           <a:bodyPr wrap="square" lIns="0" tIns="0" rIns="0" bIns="0" rtlCol="0" anchor="ctr"/>
           <a:lstStyle/>
           <a:p>
-            <a:pPr algn="ctr" indent="0" marL="0">
+            <a:pPr marL="0" indent="0" algn="ctr">
               <a:buNone/>
             </a:pPr>
             <a:r>
@@ -7691,7 +7783,7 @@
           <a:bodyPr wrap="square" lIns="0" tIns="0" rIns="0" bIns="0" rtlCol="0" anchor="ctr"/>
           <a:lstStyle/>
           <a:p>
-            <a:pPr indent="0" marL="0">
+            <a:pPr marL="0" indent="0">
               <a:buNone/>
             </a:pPr>
             <a:r>
@@ -7730,6 +7822,13 @@
           </a:solidFill>
           <a:ln/>
         </p:spPr>
+        <p:txBody>
+          <a:bodyPr/>
+          <a:lstStyle/>
+          <a:p>
+            <a:endParaRPr lang="en-US"/>
+          </a:p>
+        </p:txBody>
       </p:sp>
       <p:sp>
         <p:nvSpPr>
@@ -7752,7 +7851,7 @@
           <a:bodyPr wrap="square" lIns="0" tIns="0" rIns="0" bIns="0" rtlCol="0" anchor="ctr"/>
           <a:lstStyle/>
           <a:p>
-            <a:pPr algn="ctr" indent="0" marL="0">
+            <a:pPr marL="0" indent="0" algn="ctr">
               <a:buNone/>
             </a:pPr>
             <a:r>
@@ -7791,7 +7890,7 @@
           <a:bodyPr wrap="square" lIns="0" tIns="0" rIns="0" bIns="0" rtlCol="0" anchor="ctr"/>
           <a:lstStyle/>
           <a:p>
-            <a:pPr indent="0" marL="0">
+            <a:pPr marL="0" indent="0">
               <a:buNone/>
             </a:pPr>
             <a:r>
@@ -7830,6 +7929,13 @@
           </a:solidFill>
           <a:ln/>
         </p:spPr>
+        <p:txBody>
+          <a:bodyPr/>
+          <a:lstStyle/>
+          <a:p>
+            <a:endParaRPr lang="en-US"/>
+          </a:p>
+        </p:txBody>
       </p:sp>
       <p:sp>
         <p:nvSpPr>
@@ -7852,7 +7958,7 @@
           <a:bodyPr wrap="square" lIns="0" tIns="0" rIns="0" bIns="0" rtlCol="0" anchor="ctr"/>
           <a:lstStyle/>
           <a:p>
-            <a:pPr algn="ctr" indent="0" marL="0">
+            <a:pPr marL="0" indent="0" algn="ctr">
               <a:buNone/>
             </a:pPr>
             <a:r>
@@ -7891,7 +7997,7 @@
           <a:bodyPr wrap="square" lIns="0" tIns="0" rIns="0" bIns="0" rtlCol="0" anchor="ctr"/>
           <a:lstStyle/>
           <a:p>
-            <a:pPr indent="0" marL="0">
+            <a:pPr marL="0" indent="0">
               <a:buNone/>
             </a:pPr>
             <a:r>
@@ -7930,6 +8036,13 @@
           </a:solidFill>
           <a:ln/>
         </p:spPr>
+        <p:txBody>
+          <a:bodyPr/>
+          <a:lstStyle/>
+          <a:p>
+            <a:endParaRPr lang="en-US"/>
+          </a:p>
+        </p:txBody>
       </p:sp>
       <p:sp>
         <p:nvSpPr>
@@ -7952,7 +8065,7 @@
           <a:bodyPr wrap="square" lIns="0" tIns="0" rIns="0" bIns="0" rtlCol="0" anchor="ctr"/>
           <a:lstStyle/>
           <a:p>
-            <a:pPr algn="ctr" indent="0" marL="0">
+            <a:pPr marL="0" indent="0" algn="ctr">
               <a:buNone/>
             </a:pPr>
             <a:r>
@@ -7991,7 +8104,7 @@
           <a:bodyPr wrap="square" lIns="0" tIns="0" rIns="0" bIns="0" rtlCol="0" anchor="ctr"/>
           <a:lstStyle/>
           <a:p>
-            <a:pPr indent="0" marL="0">
+            <a:pPr marL="0" indent="0">
               <a:buNone/>
             </a:pPr>
             <a:r>
@@ -8030,6 +8143,13 @@
           </a:solidFill>
           <a:ln/>
         </p:spPr>
+        <p:txBody>
+          <a:bodyPr/>
+          <a:lstStyle/>
+          <a:p>
+            <a:endParaRPr lang="en-US"/>
+          </a:p>
+        </p:txBody>
       </p:sp>
       <p:sp>
         <p:nvSpPr>
@@ -8052,7 +8172,7 @@
           <a:bodyPr wrap="square" lIns="0" tIns="0" rIns="0" bIns="0" rtlCol="0" anchor="ctr"/>
           <a:lstStyle/>
           <a:p>
-            <a:pPr algn="ctr" indent="0" marL="0">
+            <a:pPr marL="0" indent="0" algn="ctr">
               <a:buNone/>
             </a:pPr>
             <a:r>
@@ -8091,7 +8211,7 @@
           <a:bodyPr wrap="square" lIns="0" tIns="0" rIns="0" bIns="0" rtlCol="0" anchor="ctr"/>
           <a:lstStyle/>
           <a:p>
-            <a:pPr indent="0" marL="0">
+            <a:pPr marL="0" indent="0">
               <a:buNone/>
             </a:pPr>
             <a:r>
@@ -8130,6 +8250,13 @@
           </a:solidFill>
           <a:ln/>
         </p:spPr>
+        <p:txBody>
+          <a:bodyPr/>
+          <a:lstStyle/>
+          <a:p>
+            <a:endParaRPr lang="en-US"/>
+          </a:p>
+        </p:txBody>
       </p:sp>
       <p:sp>
         <p:nvSpPr>
@@ -8152,7 +8279,7 @@
           <a:bodyPr wrap="square" lIns="0" tIns="0" rIns="0" bIns="0" rtlCol="0" anchor="ctr"/>
           <a:lstStyle/>
           <a:p>
-            <a:pPr algn="ctr" indent="0" marL="0">
+            <a:pPr marL="0" indent="0" algn="ctr">
               <a:buNone/>
             </a:pPr>
             <a:r>
@@ -8191,7 +8318,7 @@
           <a:bodyPr wrap="square" lIns="0" tIns="0" rIns="0" bIns="0" rtlCol="0" anchor="ctr"/>
           <a:lstStyle/>
           <a:p>
-            <a:pPr indent="0" marL="0">
+            <a:pPr marL="0" indent="0">
               <a:buNone/>
             </a:pPr>
             <a:r>
@@ -8510,4 +8637,319 @@
     </a:ext>
   </a:extLst>
 </a:theme>
+</file>
+
+<file path=ppt/theme/theme2.xml><?xml version="1.0" encoding="utf-8"?>
+<a:theme xmlns:a="http://schemas.openxmlformats.org/drawingml/2006/main" name="Office Theme">
+  <a:themeElements>
+    <a:clrScheme name="Office">
+      <a:dk1>
+        <a:sysClr val="windowText" lastClr="000000"/>
+      </a:dk1>
+      <a:lt1>
+        <a:sysClr val="window" lastClr="FFFFFF"/>
+      </a:lt1>
+      <a:dk2>
+        <a:srgbClr val="0E2841"/>
+      </a:dk2>
+      <a:lt2>
+        <a:srgbClr val="E8E8E8"/>
+      </a:lt2>
+      <a:accent1>
+        <a:srgbClr val="156082"/>
+      </a:accent1>
+      <a:accent2>
+        <a:srgbClr val="E97132"/>
+      </a:accent2>
+      <a:accent3>
+        <a:srgbClr val="196B24"/>
+      </a:accent3>
+      <a:accent4>
+        <a:srgbClr val="0F9ED5"/>
+      </a:accent4>
+      <a:accent5>
+        <a:srgbClr val="A02B93"/>
+      </a:accent5>
+      <a:accent6>
+        <a:srgbClr val="4EA72E"/>
+      </a:accent6>
+      <a:hlink>
+        <a:srgbClr val="467886"/>
+      </a:hlink>
+      <a:folHlink>
+        <a:srgbClr val="96607D"/>
+      </a:folHlink>
+    </a:clrScheme>
+    <a:fontScheme name="Office">
+      <a:majorFont>
+        <a:latin typeface="Aptos Display" panose="02110004020202020204"/>
+        <a:ea typeface=""/>
+        <a:cs typeface=""/>
+        <a:font script="Jpan" typeface="游ゴシック Light"/>
+        <a:font script="Hang" typeface="맑은 고딕"/>
+        <a:font script="Hans" typeface="等线 Light"/>
+        <a:font script="Hant" typeface="新細明體"/>
+        <a:font script="Arab" typeface="Times New Roman"/>
+        <a:font script="Hebr" typeface="Times New Roman"/>
+        <a:font script="Thai" typeface="Angsana New"/>
+        <a:font script="Ethi" typeface="Nyala"/>
+        <a:font script="Beng" typeface="Vrinda"/>
+        <a:font script="Gujr" typeface="Shruti"/>
+        <a:font script="Khmr" typeface="MoolBoran"/>
+        <a:font script="Knda" typeface="Tunga"/>
+        <a:font script="Guru" typeface="Raavi"/>
+        <a:font script="Cans" typeface="Euphemia"/>
+        <a:font script="Cher" typeface="Plantagenet Cherokee"/>
+        <a:font script="Yiii" typeface="Microsoft Yi Baiti"/>
+        <a:font script="Tibt" typeface="Microsoft Himalaya"/>
+        <a:font script="Thaa" typeface="MV Boli"/>
+        <a:font script="Deva" typeface="Mangal"/>
+        <a:font script="Telu" typeface="Gautami"/>
+        <a:font script="Taml" typeface="Latha"/>
+        <a:font script="Syrc" typeface="Estrangelo Edessa"/>
+        <a:font script="Orya" typeface="Kalinga"/>
+        <a:font script="Mlym" typeface="Kartika"/>
+        <a:font script="Laoo" typeface="DokChampa"/>
+        <a:font script="Sinh" typeface="Iskoola Pota"/>
+        <a:font script="Mong" typeface="Mongolian Baiti"/>
+        <a:font script="Viet" typeface="Times New Roman"/>
+        <a:font script="Uigh" typeface="Microsoft Uighur"/>
+        <a:font script="Geor" typeface="Sylfaen"/>
+        <a:font script="Armn" typeface="Arial"/>
+        <a:font script="Bugi" typeface="Leelawadee UI"/>
+        <a:font script="Bopo" typeface="Microsoft JhengHei"/>
+        <a:font script="Java" typeface="Javanese Text"/>
+        <a:font script="Lisu" typeface="Segoe UI"/>
+        <a:font script="Mymr" typeface="Myanmar Text"/>
+        <a:font script="Nkoo" typeface="Ebrima"/>
+        <a:font script="Olck" typeface="Nirmala UI"/>
+        <a:font script="Osma" typeface="Ebrima"/>
+        <a:font script="Phag" typeface="Phagspa"/>
+        <a:font script="Syrn" typeface="Estrangelo Edessa"/>
+        <a:font script="Syrj" typeface="Estrangelo Edessa"/>
+        <a:font script="Syre" typeface="Estrangelo Edessa"/>
+        <a:font script="Sora" typeface="Nirmala UI"/>
+        <a:font script="Tale" typeface="Microsoft Tai Le"/>
+        <a:font script="Talu" typeface="Microsoft New Tai Lue"/>
+        <a:font script="Tfng" typeface="Ebrima"/>
+      </a:majorFont>
+      <a:minorFont>
+        <a:latin typeface="Aptos" panose="02110004020202020204"/>
+        <a:ea typeface=""/>
+        <a:cs typeface=""/>
+        <a:font script="Jpan" typeface="游ゴシック"/>
+        <a:font script="Hang" typeface="맑은 고딕"/>
+        <a:font script="Hans" typeface="等线"/>
+        <a:font script="Hant" typeface="新細明體"/>
+        <a:font script="Arab" typeface="Arial"/>
+        <a:font script="Hebr" typeface="Arial"/>
+        <a:font script="Thai" typeface="Cordia New"/>
+        <a:font script="Ethi" typeface="Nyala"/>
+        <a:font script="Beng" typeface="Vrinda"/>
+        <a:font script="Gujr" typeface="Shruti"/>
+        <a:font script="Khmr" typeface="DaunPenh"/>
+        <a:font script="Knda" typeface="Tunga"/>
+        <a:font script="Guru" typeface="Raavi"/>
+        <a:font script="Cans" typeface="Euphemia"/>
+        <a:font script="Cher" typeface="Plantagenet Cherokee"/>
+        <a:font script="Yiii" typeface="Microsoft Yi Baiti"/>
+        <a:font script="Tibt" typeface="Microsoft Himalaya"/>
+        <a:font script="Thaa" typeface="MV Boli"/>
+        <a:font script="Deva" typeface="Mangal"/>
+        <a:font script="Telu" typeface="Gautami"/>
+        <a:font script="Taml" typeface="Latha"/>
+        <a:font script="Syrc" typeface="Estrangelo Edessa"/>
+        <a:font script="Orya" typeface="Kalinga"/>
+        <a:font script="Mlym" typeface="Kartika"/>
+        <a:font script="Laoo" typeface="DokChampa"/>
+        <a:font script="Sinh" typeface="Iskoola Pota"/>
+        <a:font script="Mong" typeface="Mongolian Baiti"/>
+        <a:font script="Viet" typeface="Arial"/>
+        <a:font script="Uigh" typeface="Microsoft Uighur"/>
+        <a:font script="Geor" typeface="Sylfaen"/>
+        <a:font script="Armn" typeface="Arial"/>
+        <a:font script="Bugi" typeface="Leelawadee UI"/>
+        <a:font script="Bopo" typeface="Microsoft JhengHei"/>
+        <a:font script="Java" typeface="Javanese Text"/>
+        <a:font script="Lisu" typeface="Segoe UI"/>
+        <a:font script="Mymr" typeface="Myanmar Text"/>
+        <a:font script="Nkoo" typeface="Ebrima"/>
+        <a:font script="Olck" typeface="Nirmala UI"/>
+        <a:font script="Osma" typeface="Ebrima"/>
+        <a:font script="Phag" typeface="Phagspa"/>
+        <a:font script="Syrn" typeface="Estrangelo Edessa"/>
+        <a:font script="Syrj" typeface="Estrangelo Edessa"/>
+        <a:font script="Syre" typeface="Estrangelo Edessa"/>
+        <a:font script="Sora" typeface="Nirmala UI"/>
+        <a:font script="Tale" typeface="Microsoft Tai Le"/>
+        <a:font script="Talu" typeface="Microsoft New Tai Lue"/>
+        <a:font script="Tfng" typeface="Ebrima"/>
+      </a:minorFont>
+    </a:fontScheme>
+    <a:fmtScheme name="Office">
+      <a:fillStyleLst>
+        <a:solidFill>
+          <a:schemeClr val="phClr"/>
+        </a:solidFill>
+        <a:gradFill rotWithShape="1">
+          <a:gsLst>
+            <a:gs pos="0">
+              <a:schemeClr val="phClr">
+                <a:lumMod val="110000"/>
+                <a:satMod val="105000"/>
+                <a:tint val="67000"/>
+              </a:schemeClr>
+            </a:gs>
+            <a:gs pos="50000">
+              <a:schemeClr val="phClr">
+                <a:lumMod val="105000"/>
+                <a:satMod val="103000"/>
+                <a:tint val="73000"/>
+              </a:schemeClr>
+            </a:gs>
+            <a:gs pos="100000">
+              <a:schemeClr val="phClr">
+                <a:lumMod val="105000"/>
+                <a:satMod val="109000"/>
+                <a:tint val="81000"/>
+              </a:schemeClr>
+            </a:gs>
+          </a:gsLst>
+          <a:lin ang="5400000" scaled="0"/>
+        </a:gradFill>
+        <a:gradFill rotWithShape="1">
+          <a:gsLst>
+            <a:gs pos="0">
+              <a:schemeClr val="phClr">
+                <a:satMod val="103000"/>
+                <a:lumMod val="102000"/>
+                <a:tint val="94000"/>
+              </a:schemeClr>
+            </a:gs>
+            <a:gs pos="50000">
+              <a:schemeClr val="phClr">
+                <a:satMod val="110000"/>
+                <a:lumMod val="100000"/>
+                <a:shade val="100000"/>
+              </a:schemeClr>
+            </a:gs>
+            <a:gs pos="100000">
+              <a:schemeClr val="phClr">
+                <a:lumMod val="99000"/>
+                <a:satMod val="120000"/>
+                <a:shade val="78000"/>
+              </a:schemeClr>
+            </a:gs>
+          </a:gsLst>
+          <a:lin ang="5400000" scaled="0"/>
+        </a:gradFill>
+      </a:fillStyleLst>
+      <a:lnStyleLst>
+        <a:ln w="12700" cap="flat" cmpd="sng" algn="ctr">
+          <a:solidFill>
+            <a:schemeClr val="phClr"/>
+          </a:solidFill>
+          <a:prstDash val="solid"/>
+          <a:miter lim="800000"/>
+        </a:ln>
+        <a:ln w="19050" cap="flat" cmpd="sng" algn="ctr">
+          <a:solidFill>
+            <a:schemeClr val="phClr"/>
+          </a:solidFill>
+          <a:prstDash val="solid"/>
+          <a:miter lim="800000"/>
+        </a:ln>
+        <a:ln w="25400" cap="flat" cmpd="sng" algn="ctr">
+          <a:solidFill>
+            <a:schemeClr val="phClr"/>
+          </a:solidFill>
+          <a:prstDash val="solid"/>
+          <a:miter lim="800000"/>
+        </a:ln>
+      </a:lnStyleLst>
+      <a:effectStyleLst>
+        <a:effectStyle>
+          <a:effectLst/>
+        </a:effectStyle>
+        <a:effectStyle>
+          <a:effectLst/>
+        </a:effectStyle>
+        <a:effectStyle>
+          <a:effectLst>
+            <a:outerShdw blurRad="57150" dist="19050" dir="5400000" algn="ctr" rotWithShape="0">
+              <a:srgbClr val="000000">
+                <a:alpha val="63000"/>
+              </a:srgbClr>
+            </a:outerShdw>
+          </a:effectLst>
+        </a:effectStyle>
+      </a:effectStyleLst>
+      <a:bgFillStyleLst>
+        <a:solidFill>
+          <a:schemeClr val="phClr"/>
+        </a:solidFill>
+        <a:solidFill>
+          <a:schemeClr val="phClr">
+            <a:tint val="95000"/>
+            <a:satMod val="170000"/>
+          </a:schemeClr>
+        </a:solidFill>
+        <a:gradFill rotWithShape="1">
+          <a:gsLst>
+            <a:gs pos="0">
+              <a:schemeClr val="phClr">
+                <a:tint val="93000"/>
+                <a:satMod val="150000"/>
+                <a:shade val="98000"/>
+                <a:lumMod val="102000"/>
+              </a:schemeClr>
+            </a:gs>
+            <a:gs pos="50000">
+              <a:schemeClr val="phClr">
+                <a:tint val="98000"/>
+                <a:satMod val="130000"/>
+                <a:shade val="90000"/>
+                <a:lumMod val="103000"/>
+              </a:schemeClr>
+            </a:gs>
+            <a:gs pos="100000">
+              <a:schemeClr val="phClr">
+                <a:shade val="63000"/>
+                <a:satMod val="120000"/>
+              </a:schemeClr>
+            </a:gs>
+          </a:gsLst>
+          <a:lin ang="5400000" scaled="0"/>
+        </a:gradFill>
+      </a:bgFillStyleLst>
+    </a:fmtScheme>
+  </a:themeElements>
+  <a:objectDefaults>
+    <a:lnDef>
+      <a:spPr/>
+      <a:bodyPr/>
+      <a:lstStyle/>
+      <a:style>
+        <a:lnRef idx="2">
+          <a:schemeClr val="accent1"/>
+        </a:lnRef>
+        <a:fillRef idx="0">
+          <a:schemeClr val="accent1"/>
+        </a:fillRef>
+        <a:effectRef idx="1">
+          <a:schemeClr val="accent1"/>
+        </a:effectRef>
+        <a:fontRef idx="minor">
+          <a:schemeClr val="tx1"/>
+        </a:fontRef>
+      </a:style>
+    </a:lnDef>
+  </a:objectDefaults>
+  <a:extraClrSchemeLst/>
+  <a:extLst>
+    <a:ext uri="{05A4C25C-085E-4340-85A3-A5531E510DB2}">
+      <thm15:themeFamily xmlns:thm15="http://schemas.microsoft.com/office/thememl/2012/main" name="Office Theme" id="{2E142A2C-CD16-42D6-873A-C26D2A0506FA}" vid="{1BDDFF52-6CD6-40A5-AB3C-68EB2F1E4D0A}"/>
+    </a:ext>
+  </a:extLst>
+</a:theme>
 </file>
</xml_diff>